<commit_message>
lecture ready(0923) : Java PPT 실습 수정
</commit_message>
<xml_diff>
--- a/material/[SeSAC_YDP_6] 38_Java_배열.pptx
+++ b/material/[SeSAC_YDP_6] 38_Java_배열.pptx
@@ -4,6 +4,9 @@
   <p:sldMasterIdLst>
     <p:sldMasterId id="2147483685" r:id="rId1"/>
   </p:sldMasterIdLst>
+  <p:notesMasterIdLst>
+    <p:notesMasterId r:id="rId17"/>
+  </p:notesMasterIdLst>
   <p:sldIdLst>
     <p:sldId id="279" r:id="rId2"/>
     <p:sldId id="280" r:id="rId3"/>
@@ -12,14 +15,14 @@
     <p:sldId id="261" r:id="rId6"/>
     <p:sldId id="262" r:id="rId7"/>
     <p:sldId id="265" r:id="rId8"/>
-    <p:sldId id="276" r:id="rId9"/>
+    <p:sldId id="286" r:id="rId9"/>
     <p:sldId id="277" r:id="rId10"/>
     <p:sldId id="278" r:id="rId11"/>
     <p:sldId id="281" r:id="rId12"/>
     <p:sldId id="267" r:id="rId13"/>
     <p:sldId id="268" r:id="rId14"/>
     <p:sldId id="269" r:id="rId15"/>
-    <p:sldId id="275" r:id="rId16"/>
+    <p:sldId id="287" r:id="rId16"/>
   </p:sldIdLst>
   <p:sldSz cx="12192000" cy="6858000"/>
   <p:notesSz cx="6858000" cy="9144000"/>
@@ -126,6 +129,523 @@
 </p:presentation>
 </file>
 
+<file path=ppt/notesMasters/notesMaster1.xml><?xml version="1.0" encoding="utf-8"?>
+<p:notesMaster xmlns:a="http://schemas.openxmlformats.org/drawingml/2006/main" xmlns:r="http://schemas.openxmlformats.org/officeDocument/2006/relationships" xmlns:p="http://schemas.openxmlformats.org/presentationml/2006/main">
+  <p:cSld>
+    <p:bg>
+      <p:bgRef idx="1001">
+        <a:schemeClr val="bg1"/>
+      </p:bgRef>
+    </p:bg>
+    <p:spTree>
+      <p:nvGrpSpPr>
+        <p:cNvPr id="1" name=""/>
+        <p:cNvGrpSpPr/>
+        <p:nvPr/>
+      </p:nvGrpSpPr>
+      <p:grpSpPr>
+        <a:xfrm>
+          <a:off x="0" y="0"/>
+          <a:ext cx="0" cy="0"/>
+          <a:chOff x="0" y="0"/>
+          <a:chExt cx="0" cy="0"/>
+        </a:xfrm>
+      </p:grpSpPr>
+      <p:sp>
+        <p:nvSpPr>
+          <p:cNvPr id="2" name="머리글 개체 틀 1"/>
+          <p:cNvSpPr>
+            <a:spLocks noGrp="1"/>
+          </p:cNvSpPr>
+          <p:nvPr>
+            <p:ph type="hdr" sz="quarter"/>
+          </p:nvPr>
+        </p:nvSpPr>
+        <p:spPr>
+          <a:xfrm>
+            <a:off x="0" y="0"/>
+            <a:ext cx="2971800" cy="458788"/>
+          </a:xfrm>
+          <a:prstGeom prst="rect">
+            <a:avLst/>
+          </a:prstGeom>
+        </p:spPr>
+        <p:txBody>
+          <a:bodyPr vert="horz" lIns="91440" tIns="45720" rIns="91440" bIns="45720" rtlCol="0"/>
+          <a:lstStyle>
+            <a:lvl1pPr algn="l">
+              <a:defRPr sz="1200"/>
+            </a:lvl1pPr>
+          </a:lstStyle>
+          <a:p>
+            <a:endParaRPr lang="ko-KR" altLang="en-US"/>
+          </a:p>
+        </p:txBody>
+      </p:sp>
+      <p:sp>
+        <p:nvSpPr>
+          <p:cNvPr id="3" name="날짜 개체 틀 2"/>
+          <p:cNvSpPr>
+            <a:spLocks noGrp="1"/>
+          </p:cNvSpPr>
+          <p:nvPr>
+            <p:ph type="dt" idx="1"/>
+          </p:nvPr>
+        </p:nvSpPr>
+        <p:spPr>
+          <a:xfrm>
+            <a:off x="3884613" y="0"/>
+            <a:ext cx="2971800" cy="458788"/>
+          </a:xfrm>
+          <a:prstGeom prst="rect">
+            <a:avLst/>
+          </a:prstGeom>
+        </p:spPr>
+        <p:txBody>
+          <a:bodyPr vert="horz" lIns="91440" tIns="45720" rIns="91440" bIns="45720" rtlCol="0"/>
+          <a:lstStyle>
+            <a:lvl1pPr algn="r">
+              <a:defRPr sz="1200"/>
+            </a:lvl1pPr>
+          </a:lstStyle>
+          <a:p>
+            <a:fld id="{D7EA8447-AFDC-4B64-BE3E-67E61D702092}" type="datetimeFigureOut">
+              <a:rPr lang="ko-KR" altLang="en-US" smtClean="0"/>
+              <a:t>2024-09-23</a:t>
+            </a:fld>
+            <a:endParaRPr lang="ko-KR" altLang="en-US"/>
+          </a:p>
+        </p:txBody>
+      </p:sp>
+      <p:sp>
+        <p:nvSpPr>
+          <p:cNvPr id="4" name="슬라이드 이미지 개체 틀 3"/>
+          <p:cNvSpPr>
+            <a:spLocks noGrp="1" noRot="1" noChangeAspect="1"/>
+          </p:cNvSpPr>
+          <p:nvPr>
+            <p:ph type="sldImg" idx="2"/>
+          </p:nvPr>
+        </p:nvSpPr>
+        <p:spPr>
+          <a:xfrm>
+            <a:off x="685800" y="1143000"/>
+            <a:ext cx="5486400" cy="3086100"/>
+          </a:xfrm>
+          <a:prstGeom prst="rect">
+            <a:avLst/>
+          </a:prstGeom>
+          <a:noFill/>
+          <a:ln w="12700">
+            <a:solidFill>
+              <a:prstClr val="black"/>
+            </a:solidFill>
+          </a:ln>
+        </p:spPr>
+        <p:txBody>
+          <a:bodyPr vert="horz" lIns="91440" tIns="45720" rIns="91440" bIns="45720" rtlCol="0" anchor="ctr"/>
+          <a:lstStyle/>
+          <a:p>
+            <a:endParaRPr lang="ko-KR" altLang="en-US"/>
+          </a:p>
+        </p:txBody>
+      </p:sp>
+      <p:sp>
+        <p:nvSpPr>
+          <p:cNvPr id="5" name="슬라이드 노트 개체 틀 4"/>
+          <p:cNvSpPr>
+            <a:spLocks noGrp="1"/>
+          </p:cNvSpPr>
+          <p:nvPr>
+            <p:ph type="body" sz="quarter" idx="3"/>
+          </p:nvPr>
+        </p:nvSpPr>
+        <p:spPr>
+          <a:xfrm>
+            <a:off x="685800" y="4400550"/>
+            <a:ext cx="5486400" cy="3600450"/>
+          </a:xfrm>
+          <a:prstGeom prst="rect">
+            <a:avLst/>
+          </a:prstGeom>
+        </p:spPr>
+        <p:txBody>
+          <a:bodyPr vert="horz" lIns="91440" tIns="45720" rIns="91440" bIns="45720" rtlCol="0"/>
+          <a:lstStyle/>
+          <a:p>
+            <a:pPr lvl="0"/>
+            <a:r>
+              <a:rPr lang="ko-KR" altLang="en-US"/>
+              <a:t>마스터 텍스트 스타일을 편집하려면 클릭</a:t>
+            </a:r>
+          </a:p>
+          <a:p>
+            <a:pPr lvl="1"/>
+            <a:r>
+              <a:rPr lang="ko-KR" altLang="en-US"/>
+              <a:t>두 번째 수준</a:t>
+            </a:r>
+          </a:p>
+          <a:p>
+            <a:pPr lvl="2"/>
+            <a:r>
+              <a:rPr lang="ko-KR" altLang="en-US"/>
+              <a:t>세 번째 수준</a:t>
+            </a:r>
+          </a:p>
+          <a:p>
+            <a:pPr lvl="3"/>
+            <a:r>
+              <a:rPr lang="ko-KR" altLang="en-US"/>
+              <a:t>네 번째 수준</a:t>
+            </a:r>
+          </a:p>
+          <a:p>
+            <a:pPr lvl="4"/>
+            <a:r>
+              <a:rPr lang="ko-KR" altLang="en-US"/>
+              <a:t>다섯 번째 수준</a:t>
+            </a:r>
+          </a:p>
+        </p:txBody>
+      </p:sp>
+      <p:sp>
+        <p:nvSpPr>
+          <p:cNvPr id="6" name="바닥글 개체 틀 5"/>
+          <p:cNvSpPr>
+            <a:spLocks noGrp="1"/>
+          </p:cNvSpPr>
+          <p:nvPr>
+            <p:ph type="ftr" sz="quarter" idx="4"/>
+          </p:nvPr>
+        </p:nvSpPr>
+        <p:spPr>
+          <a:xfrm>
+            <a:off x="0" y="8685213"/>
+            <a:ext cx="2971800" cy="458787"/>
+          </a:xfrm>
+          <a:prstGeom prst="rect">
+            <a:avLst/>
+          </a:prstGeom>
+        </p:spPr>
+        <p:txBody>
+          <a:bodyPr vert="horz" lIns="91440" tIns="45720" rIns="91440" bIns="45720" rtlCol="0" anchor="b"/>
+          <a:lstStyle>
+            <a:lvl1pPr algn="l">
+              <a:defRPr sz="1200"/>
+            </a:lvl1pPr>
+          </a:lstStyle>
+          <a:p>
+            <a:endParaRPr lang="ko-KR" altLang="en-US"/>
+          </a:p>
+        </p:txBody>
+      </p:sp>
+      <p:sp>
+        <p:nvSpPr>
+          <p:cNvPr id="7" name="슬라이드 번호 개체 틀 6"/>
+          <p:cNvSpPr>
+            <a:spLocks noGrp="1"/>
+          </p:cNvSpPr>
+          <p:nvPr>
+            <p:ph type="sldNum" sz="quarter" idx="5"/>
+          </p:nvPr>
+        </p:nvSpPr>
+        <p:spPr>
+          <a:xfrm>
+            <a:off x="3884613" y="8685213"/>
+            <a:ext cx="2971800" cy="458787"/>
+          </a:xfrm>
+          <a:prstGeom prst="rect">
+            <a:avLst/>
+          </a:prstGeom>
+        </p:spPr>
+        <p:txBody>
+          <a:bodyPr vert="horz" lIns="91440" tIns="45720" rIns="91440" bIns="45720" rtlCol="0" anchor="b"/>
+          <a:lstStyle>
+            <a:lvl1pPr algn="r">
+              <a:defRPr sz="1200"/>
+            </a:lvl1pPr>
+          </a:lstStyle>
+          <a:p>
+            <a:fld id="{F0FE4C89-F346-4A7E-B2E2-B28DD61E05A1}" type="slidenum">
+              <a:rPr lang="ko-KR" altLang="en-US" smtClean="0"/>
+              <a:t>‹#›</a:t>
+            </a:fld>
+            <a:endParaRPr lang="ko-KR" altLang="en-US"/>
+          </a:p>
+        </p:txBody>
+      </p:sp>
+    </p:spTree>
+    <p:extLst>
+      <p:ext uri="{BB962C8B-B14F-4D97-AF65-F5344CB8AC3E}">
+        <p14:creationId xmlns:p14="http://schemas.microsoft.com/office/powerpoint/2010/main" val="523319483"/>
+      </p:ext>
+    </p:extLst>
+  </p:cSld>
+  <p:clrMap bg1="lt1" tx1="dk1" bg2="lt2" tx2="dk2" accent1="accent1" accent2="accent2" accent3="accent3" accent4="accent4" accent5="accent5" accent6="accent6" hlink="hlink" folHlink="folHlink"/>
+  <p:notesStyle>
+    <a:lvl1pPr marL="0" algn="l" defTabSz="914400" rtl="0" eaLnBrk="1" latinLnBrk="1" hangingPunct="1">
+      <a:defRPr sz="1200" kern="1200">
+        <a:solidFill>
+          <a:schemeClr val="tx1"/>
+        </a:solidFill>
+        <a:latin typeface="+mn-lt"/>
+        <a:ea typeface="+mn-ea"/>
+        <a:cs typeface="+mn-cs"/>
+      </a:defRPr>
+    </a:lvl1pPr>
+    <a:lvl2pPr marL="457200" algn="l" defTabSz="914400" rtl="0" eaLnBrk="1" latinLnBrk="1" hangingPunct="1">
+      <a:defRPr sz="1200" kern="1200">
+        <a:solidFill>
+          <a:schemeClr val="tx1"/>
+        </a:solidFill>
+        <a:latin typeface="+mn-lt"/>
+        <a:ea typeface="+mn-ea"/>
+        <a:cs typeface="+mn-cs"/>
+      </a:defRPr>
+    </a:lvl2pPr>
+    <a:lvl3pPr marL="914400" algn="l" defTabSz="914400" rtl="0" eaLnBrk="1" latinLnBrk="1" hangingPunct="1">
+      <a:defRPr sz="1200" kern="1200">
+        <a:solidFill>
+          <a:schemeClr val="tx1"/>
+        </a:solidFill>
+        <a:latin typeface="+mn-lt"/>
+        <a:ea typeface="+mn-ea"/>
+        <a:cs typeface="+mn-cs"/>
+      </a:defRPr>
+    </a:lvl3pPr>
+    <a:lvl4pPr marL="1371600" algn="l" defTabSz="914400" rtl="0" eaLnBrk="1" latinLnBrk="1" hangingPunct="1">
+      <a:defRPr sz="1200" kern="1200">
+        <a:solidFill>
+          <a:schemeClr val="tx1"/>
+        </a:solidFill>
+        <a:latin typeface="+mn-lt"/>
+        <a:ea typeface="+mn-ea"/>
+        <a:cs typeface="+mn-cs"/>
+      </a:defRPr>
+    </a:lvl4pPr>
+    <a:lvl5pPr marL="1828800" algn="l" defTabSz="914400" rtl="0" eaLnBrk="1" latinLnBrk="1" hangingPunct="1">
+      <a:defRPr sz="1200" kern="1200">
+        <a:solidFill>
+          <a:schemeClr val="tx1"/>
+        </a:solidFill>
+        <a:latin typeface="+mn-lt"/>
+        <a:ea typeface="+mn-ea"/>
+        <a:cs typeface="+mn-cs"/>
+      </a:defRPr>
+    </a:lvl5pPr>
+    <a:lvl6pPr marL="2286000" algn="l" defTabSz="914400" rtl="0" eaLnBrk="1" latinLnBrk="1" hangingPunct="1">
+      <a:defRPr sz="1200" kern="1200">
+        <a:solidFill>
+          <a:schemeClr val="tx1"/>
+        </a:solidFill>
+        <a:latin typeface="+mn-lt"/>
+        <a:ea typeface="+mn-ea"/>
+        <a:cs typeface="+mn-cs"/>
+      </a:defRPr>
+    </a:lvl6pPr>
+    <a:lvl7pPr marL="2743200" algn="l" defTabSz="914400" rtl="0" eaLnBrk="1" latinLnBrk="1" hangingPunct="1">
+      <a:defRPr sz="1200" kern="1200">
+        <a:solidFill>
+          <a:schemeClr val="tx1"/>
+        </a:solidFill>
+        <a:latin typeface="+mn-lt"/>
+        <a:ea typeface="+mn-ea"/>
+        <a:cs typeface="+mn-cs"/>
+      </a:defRPr>
+    </a:lvl7pPr>
+    <a:lvl8pPr marL="3200400" algn="l" defTabSz="914400" rtl="0" eaLnBrk="1" latinLnBrk="1" hangingPunct="1">
+      <a:defRPr sz="1200" kern="1200">
+        <a:solidFill>
+          <a:schemeClr val="tx1"/>
+        </a:solidFill>
+        <a:latin typeface="+mn-lt"/>
+        <a:ea typeface="+mn-ea"/>
+        <a:cs typeface="+mn-cs"/>
+      </a:defRPr>
+    </a:lvl8pPr>
+    <a:lvl9pPr marL="3657600" algn="l" defTabSz="914400" rtl="0" eaLnBrk="1" latinLnBrk="1" hangingPunct="1">
+      <a:defRPr sz="1200" kern="1200">
+        <a:solidFill>
+          <a:schemeClr val="tx1"/>
+        </a:solidFill>
+        <a:latin typeface="+mn-lt"/>
+        <a:ea typeface="+mn-ea"/>
+        <a:cs typeface="+mn-cs"/>
+      </a:defRPr>
+    </a:lvl9pPr>
+  </p:notesStyle>
+</p:notesMaster>
+</file>
+
+<file path=ppt/notesSlides/notesSlide1.xml><?xml version="1.0" encoding="utf-8"?>
+<p:notes xmlns:a="http://schemas.openxmlformats.org/drawingml/2006/main" xmlns:r="http://schemas.openxmlformats.org/officeDocument/2006/relationships" xmlns:p="http://schemas.openxmlformats.org/presentationml/2006/main">
+  <p:cSld>
+    <p:spTree>
+      <p:nvGrpSpPr>
+        <p:cNvPr id="1" name=""/>
+        <p:cNvGrpSpPr/>
+        <p:nvPr/>
+      </p:nvGrpSpPr>
+      <p:grpSpPr>
+        <a:xfrm>
+          <a:off x="0" y="0"/>
+          <a:ext cx="0" cy="0"/>
+          <a:chOff x="0" y="0"/>
+          <a:chExt cx="0" cy="0"/>
+        </a:xfrm>
+      </p:grpSpPr>
+      <p:sp>
+        <p:nvSpPr>
+          <p:cNvPr id="2" name="슬라이드 이미지 개체 틀 1"/>
+          <p:cNvSpPr>
+            <a:spLocks noGrp="1" noRot="1" noChangeAspect="1"/>
+          </p:cNvSpPr>
+          <p:nvPr>
+            <p:ph type="sldImg"/>
+          </p:nvPr>
+        </p:nvSpPr>
+        <p:spPr/>
+      </p:sp>
+      <p:sp>
+        <p:nvSpPr>
+          <p:cNvPr id="3" name="슬라이드 노트 개체 틀 2"/>
+          <p:cNvSpPr>
+            <a:spLocks noGrp="1"/>
+          </p:cNvSpPr>
+          <p:nvPr>
+            <p:ph type="body" idx="1"/>
+          </p:nvPr>
+        </p:nvSpPr>
+        <p:spPr/>
+        <p:txBody>
+          <a:bodyPr/>
+          <a:lstStyle/>
+          <a:p>
+            <a:endParaRPr lang="en-US" altLang="ko-KR" dirty="0"/>
+          </a:p>
+        </p:txBody>
+      </p:sp>
+      <p:sp>
+        <p:nvSpPr>
+          <p:cNvPr id="4" name="슬라이드 번호 개체 틀 3"/>
+          <p:cNvSpPr>
+            <a:spLocks noGrp="1"/>
+          </p:cNvSpPr>
+          <p:nvPr>
+            <p:ph type="sldNum" sz="quarter" idx="5"/>
+          </p:nvPr>
+        </p:nvSpPr>
+        <p:spPr/>
+        <p:txBody>
+          <a:bodyPr/>
+          <a:lstStyle/>
+          <a:p>
+            <a:fld id="{C09E5BFC-1559-42F1-8940-AB342D56BF02}" type="slidenum">
+              <a:rPr lang="ko-KR" altLang="en-US" smtClean="0"/>
+              <a:t>8</a:t>
+            </a:fld>
+            <a:endParaRPr lang="ko-KR" altLang="en-US"/>
+          </a:p>
+        </p:txBody>
+      </p:sp>
+    </p:spTree>
+    <p:extLst>
+      <p:ext uri="{BB962C8B-B14F-4D97-AF65-F5344CB8AC3E}">
+        <p14:creationId xmlns:p14="http://schemas.microsoft.com/office/powerpoint/2010/main" val="2353797932"/>
+      </p:ext>
+    </p:extLst>
+  </p:cSld>
+  <p:clrMapOvr>
+    <a:masterClrMapping/>
+  </p:clrMapOvr>
+</p:notes>
+</file>
+
+<file path=ppt/notesSlides/notesSlide2.xml><?xml version="1.0" encoding="utf-8"?>
+<p:notes xmlns:a="http://schemas.openxmlformats.org/drawingml/2006/main" xmlns:r="http://schemas.openxmlformats.org/officeDocument/2006/relationships" xmlns:p="http://schemas.openxmlformats.org/presentationml/2006/main">
+  <p:cSld>
+    <p:spTree>
+      <p:nvGrpSpPr>
+        <p:cNvPr id="1" name=""/>
+        <p:cNvGrpSpPr/>
+        <p:nvPr/>
+      </p:nvGrpSpPr>
+      <p:grpSpPr>
+        <a:xfrm>
+          <a:off x="0" y="0"/>
+          <a:ext cx="0" cy="0"/>
+          <a:chOff x="0" y="0"/>
+          <a:chExt cx="0" cy="0"/>
+        </a:xfrm>
+      </p:grpSpPr>
+      <p:sp>
+        <p:nvSpPr>
+          <p:cNvPr id="2" name="슬라이드 이미지 개체 틀 1"/>
+          <p:cNvSpPr>
+            <a:spLocks noGrp="1" noRot="1" noChangeAspect="1"/>
+          </p:cNvSpPr>
+          <p:nvPr>
+            <p:ph type="sldImg"/>
+          </p:nvPr>
+        </p:nvSpPr>
+        <p:spPr/>
+      </p:sp>
+      <p:sp>
+        <p:nvSpPr>
+          <p:cNvPr id="3" name="슬라이드 노트 개체 틀 2"/>
+          <p:cNvSpPr>
+            <a:spLocks noGrp="1"/>
+          </p:cNvSpPr>
+          <p:nvPr>
+            <p:ph type="body" idx="1"/>
+          </p:nvPr>
+        </p:nvSpPr>
+        <p:spPr/>
+        <p:txBody>
+          <a:bodyPr/>
+          <a:lstStyle/>
+          <a:p>
+            <a:endParaRPr lang="en-US" altLang="ko-KR" dirty="0"/>
+          </a:p>
+        </p:txBody>
+      </p:sp>
+      <p:sp>
+        <p:nvSpPr>
+          <p:cNvPr id="4" name="슬라이드 번호 개체 틀 3"/>
+          <p:cNvSpPr>
+            <a:spLocks noGrp="1"/>
+          </p:cNvSpPr>
+          <p:nvPr>
+            <p:ph type="sldNum" sz="quarter" idx="5"/>
+          </p:nvPr>
+        </p:nvSpPr>
+        <p:spPr/>
+        <p:txBody>
+          <a:bodyPr/>
+          <a:lstStyle/>
+          <a:p>
+            <a:fld id="{C09E5BFC-1559-42F1-8940-AB342D56BF02}" type="slidenum">
+              <a:rPr lang="ko-KR" altLang="en-US" smtClean="0"/>
+              <a:t>15</a:t>
+            </a:fld>
+            <a:endParaRPr lang="ko-KR" altLang="en-US"/>
+          </a:p>
+        </p:txBody>
+      </p:sp>
+    </p:spTree>
+    <p:extLst>
+      <p:ext uri="{BB962C8B-B14F-4D97-AF65-F5344CB8AC3E}">
+        <p14:creationId xmlns:p14="http://schemas.microsoft.com/office/powerpoint/2010/main" val="2353797932"/>
+      </p:ext>
+    </p:extLst>
+  </p:cSld>
+  <p:clrMapOvr>
+    <a:masterClrMapping/>
+  </p:clrMapOvr>
+</p:notes>
+</file>
+
 <file path=ppt/slideLayouts/slideLayout1.xml><?xml version="1.0" encoding="utf-8"?>
 <p:sldLayout xmlns:a="http://schemas.openxmlformats.org/drawingml/2006/main" xmlns:r="http://schemas.openxmlformats.org/officeDocument/2006/relationships" xmlns:p="http://schemas.openxmlformats.org/presentationml/2006/main" type="title" preserve="1">
   <p:cSld name="제목 슬라이드">
@@ -280,7 +800,7 @@
           <a:p>
             <a:fld id="{0E19CB95-6D28-40F1-9DA3-1BAC5D4B5B4F}" type="datetime6">
               <a:rPr lang="ko-KR" altLang="en-US" smtClean="0"/>
-              <a:t>2024년 7월</a:t>
+              <a:t>2024년 9월</a:t>
             </a:fld>
             <a:endParaRPr lang="ko-KR" altLang="en-US"/>
           </a:p>
@@ -660,7 +1180,7 @@
           <a:p>
             <a:fld id="{C4A39A32-5728-48B8-9F9C-437D214CCAF1}" type="datetime6">
               <a:rPr lang="ko-KR" altLang="en-US" smtClean="0"/>
-              <a:t>2024년 7월</a:t>
+              <a:t>2024년 9월</a:t>
             </a:fld>
             <a:endParaRPr lang="ko-KR" altLang="en-US"/>
           </a:p>
@@ -862,7 +1382,7 @@
           <a:p>
             <a:fld id="{3BECC8BA-EBCB-4BF9-8E87-970CE0138376}" type="datetime6">
               <a:rPr lang="ko-KR" altLang="en-US" smtClean="0"/>
-              <a:t>2024년 7월</a:t>
+              <a:t>2024년 9월</a:t>
             </a:fld>
             <a:endParaRPr lang="ko-KR" altLang="en-US"/>
           </a:p>
@@ -1070,7 +1590,7 @@
           <a:p>
             <a:fld id="{7869FA6E-4699-4AC6-B2CB-4E60A58ED7A8}" type="datetime6">
               <a:rPr lang="ko-KR" altLang="en-US" smtClean="0"/>
-              <a:t>2024년 7월</a:t>
+              <a:t>2024년 9월</a:t>
             </a:fld>
             <a:endParaRPr lang="ko-KR" altLang="en-US"/>
           </a:p>
@@ -1183,7 +1703,7 @@
           <a:p>
             <a:fld id="{0E19CB95-6D28-40F1-9DA3-1BAC5D4B5B4F}" type="datetime6">
               <a:rPr lang="ko-KR" altLang="en-US" smtClean="0"/>
-              <a:t>2024년 7월</a:t>
+              <a:t>2024년 9월</a:t>
             </a:fld>
             <a:endParaRPr lang="ko-KR" altLang="en-US"/>
           </a:p>
@@ -1445,7 +1965,7 @@
           <a:p>
             <a:fld id="{3C9CE3CE-253F-4F9D-BA15-C226C8D8501E}" type="datetime6">
               <a:rPr lang="ko-KR" altLang="en-US" smtClean="0"/>
-              <a:t>2024년 7월</a:t>
+              <a:t>2024년 9월</a:t>
             </a:fld>
             <a:endParaRPr lang="ko-KR" altLang="en-US"/>
           </a:p>
@@ -1762,7 +2282,7 @@
           <a:p>
             <a:fld id="{BE5A7087-D460-46DD-B430-F8D9B9677D08}" type="datetime6">
               <a:rPr lang="ko-KR" altLang="en-US" smtClean="0"/>
-              <a:t>2024년 7월</a:t>
+              <a:t>2024년 9월</a:t>
             </a:fld>
             <a:endParaRPr lang="ko-KR" altLang="en-US"/>
           </a:p>
@@ -2031,7 +2551,7 @@
           <a:p>
             <a:fld id="{0581BA25-D675-4234-A003-8449BDEEF18E}" type="datetime6">
               <a:rPr lang="ko-KR" altLang="en-US" smtClean="0"/>
-              <a:t>2024년 7월</a:t>
+              <a:t>2024년 9월</a:t>
             </a:fld>
             <a:endParaRPr lang="ko-KR" altLang="en-US"/>
           </a:p>
@@ -2447,7 +2967,7 @@
           <a:p>
             <a:fld id="{26155C29-A87F-46F0-A24C-6C9F0A4BF6AA}" type="datetime6">
               <a:rPr lang="ko-KR" altLang="en-US" smtClean="0"/>
-              <a:t>2024년 7월</a:t>
+              <a:t>2024년 9월</a:t>
             </a:fld>
             <a:endParaRPr lang="ko-KR" altLang="en-US"/>
           </a:p>
@@ -2592,7 +3112,7 @@
           <a:p>
             <a:fld id="{DD2EDD62-8757-43DB-BAE0-460422B548EA}" type="datetime6">
               <a:rPr lang="ko-KR" altLang="en-US" smtClean="0"/>
-              <a:t>2024년 7월</a:t>
+              <a:t>2024년 9월</a:t>
             </a:fld>
             <a:endParaRPr lang="ko-KR" altLang="en-US"/>
           </a:p>
@@ -2705,7 +3225,7 @@
           <a:p>
             <a:fld id="{DC6A871B-4800-495F-AC75-93D44C7DEBA5}" type="datetime6">
               <a:rPr lang="ko-KR" altLang="en-US" smtClean="0"/>
-              <a:t>2024년 7월</a:t>
+              <a:t>2024년 9월</a:t>
             </a:fld>
             <a:endParaRPr lang="ko-KR" altLang="en-US"/>
           </a:p>
@@ -3016,7 +3536,7 @@
           <a:p>
             <a:fld id="{59605888-30A6-49BB-95E2-DEAE4E5B09E9}" type="datetime6">
               <a:rPr lang="ko-KR" altLang="en-US" smtClean="0"/>
-              <a:t>2024년 7월</a:t>
+              <a:t>2024년 9월</a:t>
             </a:fld>
             <a:endParaRPr lang="ko-KR" altLang="en-US"/>
           </a:p>
@@ -3257,7 +3777,7 @@
           <a:p>
             <a:fld id="{8691C14A-5735-4A8B-B68B-DEC1DC2A3813}" type="datetime6">
               <a:rPr lang="ko-KR" altLang="en-US" smtClean="0"/>
-              <a:t>2024년 7월</a:t>
+              <a:t>2024년 9월</a:t>
             </a:fld>
             <a:endParaRPr lang="ko-KR" altLang="en-US"/>
           </a:p>
@@ -3846,7 +4366,7 @@
           <a:p>
             <a:fld id="{0E19CB95-6D28-40F1-9DA3-1BAC5D4B5B4F}" type="datetime6">
               <a:rPr lang="ko-KR" altLang="en-US" smtClean="0"/>
-              <a:t>2024년 7월</a:t>
+              <a:t>2024년 9월</a:t>
             </a:fld>
             <a:endParaRPr lang="ko-KR" altLang="en-US" dirty="0"/>
           </a:p>
@@ -4150,7 +4670,7 @@
           <a:p>
             <a:fld id="{CE27A22C-65A3-484B-AF1E-9F8BD90A2FC7}" type="datetime1">
               <a:rPr lang="ko-KR" altLang="en-US" smtClean="0"/>
-              <a:t>2024-07-05</a:t>
+              <a:t>2024-09-23</a:t>
             </a:fld>
             <a:endParaRPr lang="ko-KR" altLang="en-US"/>
           </a:p>
@@ -4264,7 +4784,7 @@
           <a:p>
             <a:fld id="{0E19CB95-6D28-40F1-9DA3-1BAC5D4B5B4F}" type="datetime6">
               <a:rPr lang="ko-KR" altLang="en-US" smtClean="0"/>
-              <a:t>2024년 7월</a:t>
+              <a:t>2024년 9월</a:t>
             </a:fld>
             <a:endParaRPr lang="ko-KR" altLang="en-US"/>
           </a:p>
@@ -4435,7 +4955,7 @@
           <a:p>
             <a:fld id="{CE27A22C-65A3-484B-AF1E-9F8BD90A2FC7}" type="datetime1">
               <a:rPr lang="ko-KR" altLang="en-US" smtClean="0"/>
-              <a:t>2024-07-05</a:t>
+              <a:t>2024-09-23</a:t>
             </a:fld>
             <a:endParaRPr lang="ko-KR" altLang="en-US"/>
           </a:p>
@@ -4839,7 +5359,7 @@
           <a:p>
             <a:fld id="{CE27A22C-65A3-484B-AF1E-9F8BD90A2FC7}" type="datetime1">
               <a:rPr lang="ko-KR" altLang="en-US" smtClean="0"/>
-              <a:t>2024-07-05</a:t>
+              <a:t>2024-09-23</a:t>
             </a:fld>
             <a:endParaRPr lang="ko-KR" altLang="en-US"/>
           </a:p>
@@ -5105,7 +5625,7 @@
           <a:p>
             <a:fld id="{CE27A22C-65A3-484B-AF1E-9F8BD90A2FC7}" type="datetime1">
               <a:rPr lang="ko-KR" altLang="en-US" smtClean="0"/>
-              <a:t>2024-07-05</a:t>
+              <a:t>2024-09-23</a:t>
             </a:fld>
             <a:endParaRPr lang="ko-KR" altLang="en-US"/>
           </a:p>
@@ -5208,10 +5728,10 @@
       </p:grpSpPr>
       <p:sp>
         <p:nvSpPr>
-          <p:cNvPr id="3" name="내용 개체 틀 2">
-            <a:extLst>
-              <a:ext uri="{FF2B5EF4-FFF2-40B4-BE49-F238E27FC236}">
-                <a16:creationId xmlns:a16="http://schemas.microsoft.com/office/drawing/2014/main" id="{48F1F3A4-1C34-E0EC-1365-0360299807D6}"/>
+          <p:cNvPr id="13" name="내용 개체 틀 2">
+            <a:extLst>
+              <a:ext uri="{FF2B5EF4-FFF2-40B4-BE49-F238E27FC236}">
+                <a16:creationId xmlns:a16="http://schemas.microsoft.com/office/drawing/2014/main" id="{847FD532-7F61-A001-537F-B970BD821AF3}"/>
               </a:ext>
             </a:extLst>
           </p:cNvPr>
@@ -5224,8 +5744,8 @@
         </p:nvSpPr>
         <p:spPr>
           <a:xfrm>
-            <a:off x="838200" y="1565213"/>
-            <a:ext cx="10826262" cy="4111688"/>
+            <a:off x="510988" y="1328391"/>
+            <a:ext cx="11260802" cy="5328442"/>
           </a:xfrm>
         </p:spPr>
         <p:txBody>
@@ -5234,71 +5754,19 @@
           </a:bodyPr>
           <a:lstStyle/>
           <a:p>
-            <a:r>
-              <a:rPr lang="en-US" altLang="ko-KR" sz="2400" dirty="0" err="1"/>
-              <a:t>ArrayList</a:t>
-            </a:r>
-            <a:r>
-              <a:rPr lang="ko-KR" altLang="en-US" sz="2400" dirty="0"/>
-              <a:t>를 만들어주세요</a:t>
-            </a:r>
-            <a:r>
-              <a:rPr lang="en-US" altLang="ko-KR" sz="2400" dirty="0"/>
-              <a:t>.</a:t>
-            </a:r>
-          </a:p>
-          <a:p>
-            <a:r>
-              <a:rPr lang="ko-KR" altLang="en-US" sz="2400" dirty="0"/>
-              <a:t>사용자로부터 문자열을 </a:t>
-            </a:r>
-            <a:r>
-              <a:rPr lang="ko-KR" altLang="en-US" sz="2400" dirty="0" err="1"/>
-              <a:t>입력받아</a:t>
-            </a:r>
-            <a:r>
-              <a:rPr lang="ko-KR" altLang="en-US" sz="2400" dirty="0"/>
-              <a:t> </a:t>
-            </a:r>
-            <a:r>
-              <a:rPr lang="en-US" altLang="ko-KR" sz="2400" dirty="0" err="1"/>
-              <a:t>ArrayList</a:t>
-            </a:r>
-            <a:r>
-              <a:rPr lang="ko-KR" altLang="en-US" sz="2400" dirty="0"/>
-              <a:t>에 넣어주세요</a:t>
-            </a:r>
-            <a:r>
-              <a:rPr lang="en-US" altLang="ko-KR" sz="2400" dirty="0"/>
-              <a:t>.</a:t>
-            </a:r>
-          </a:p>
-          <a:p>
-            <a:r>
-              <a:rPr lang="ko-KR" altLang="en-US" sz="2400" dirty="0"/>
-              <a:t>사용자가 </a:t>
-            </a:r>
-            <a:r>
-              <a:rPr lang="en-US" altLang="ko-KR" sz="2400" dirty="0"/>
-              <a:t>“exit”</a:t>
-            </a:r>
-            <a:r>
-              <a:rPr lang="ko-KR" altLang="en-US" sz="2400" dirty="0"/>
-              <a:t>이라는 값을 입력하면</a:t>
-            </a:r>
-            <a:r>
-              <a:rPr lang="en-US" altLang="ko-KR" sz="2400" dirty="0"/>
-              <a:t>, </a:t>
-            </a:r>
-            <a:r>
-              <a:rPr lang="ko-KR" altLang="en-US" sz="2400" dirty="0"/>
-              <a:t>배열 안에 있는 값을 모두 출력해주세요</a:t>
-            </a:r>
-            <a:r>
-              <a:rPr lang="en-US" altLang="ko-KR" sz="2400" dirty="0"/>
-              <a:t>.</a:t>
-            </a:r>
-            <a:endParaRPr lang="ko-KR" altLang="en-US" sz="2400" dirty="0"/>
+            <a:endParaRPr lang="en-US" altLang="ko-KR" dirty="0"/>
+          </a:p>
+          <a:p>
+            <a:pPr marL="0" indent="0">
+              <a:buNone/>
+            </a:pPr>
+            <a:endParaRPr lang="en-US" altLang="ko-KR" dirty="0"/>
+          </a:p>
+          <a:p>
+            <a:pPr marL="0" indent="0">
+              <a:buNone/>
+            </a:pPr>
+            <a:endParaRPr lang="en-US" altLang="ko-KR" dirty="0"/>
           </a:p>
         </p:txBody>
       </p:sp>
@@ -5307,7 +5775,7 @@
           <p:cNvPr id="4" name="날짜 개체 틀 3">
             <a:extLst>
               <a:ext uri="{FF2B5EF4-FFF2-40B4-BE49-F238E27FC236}">
-                <a16:creationId xmlns:a16="http://schemas.microsoft.com/office/drawing/2014/main" id="{D269450B-7D34-7D80-C05E-003E1A5F0D3D}"/>
+                <a16:creationId xmlns:a16="http://schemas.microsoft.com/office/drawing/2014/main" id="{A695DDE5-0A39-A366-4CFE-A283911999CD}"/>
               </a:ext>
             </a:extLst>
           </p:cNvPr>
@@ -5323,11 +5791,11 @@
           <a:bodyPr/>
           <a:lstStyle/>
           <a:p>
-            <a:fld id="{CE27A22C-65A3-484B-AF1E-9F8BD90A2FC7}" type="datetime1">
+            <a:fld id="{0F78D9C4-20C1-4B15-A116-16DC77AD9A1E}" type="datetime1">
               <a:rPr lang="ko-KR" altLang="en-US" smtClean="0"/>
-              <a:t>2024-07-05</a:t>
+              <a:t>2024-09-23</a:t>
             </a:fld>
-            <a:endParaRPr lang="ko-KR" altLang="en-US" dirty="0"/>
+            <a:endParaRPr lang="ko-KR" altLang="en-US"/>
           </a:p>
         </p:txBody>
       </p:sp>
@@ -5336,7 +5804,7 @@
           <p:cNvPr id="5" name="슬라이드 번호 개체 틀 4">
             <a:extLst>
               <a:ext uri="{FF2B5EF4-FFF2-40B4-BE49-F238E27FC236}">
-                <a16:creationId xmlns:a16="http://schemas.microsoft.com/office/drawing/2014/main" id="{89835C10-39B1-7735-B792-5881B339B742}"/>
+                <a16:creationId xmlns:a16="http://schemas.microsoft.com/office/drawing/2014/main" id="{5E040F43-60A7-C50D-1F5B-F984054F2D7C}"/>
               </a:ext>
             </a:extLst>
           </p:cNvPr>
@@ -5362,10 +5830,10 @@
       </p:sp>
       <p:sp>
         <p:nvSpPr>
-          <p:cNvPr id="6" name="제목 1">
-            <a:extLst>
-              <a:ext uri="{FF2B5EF4-FFF2-40B4-BE49-F238E27FC236}">
-                <a16:creationId xmlns:a16="http://schemas.microsoft.com/office/drawing/2014/main" id="{8657E4F7-9B60-A2D7-860C-6BE8D7D70F07}"/>
+          <p:cNvPr id="2" name="제목 1">
+            <a:extLst>
+              <a:ext uri="{FF2B5EF4-FFF2-40B4-BE49-F238E27FC236}">
+                <a16:creationId xmlns:a16="http://schemas.microsoft.com/office/drawing/2014/main" id="{5FAC57F5-99D7-9C46-B6C1-D16224151FE9}"/>
               </a:ext>
             </a:extLst>
           </p:cNvPr>
@@ -5384,7 +5852,7 @@
             <a:r>
               <a:rPr lang="ko-KR" altLang="en-US" dirty="0">
                 <a:solidFill>
-                  <a:schemeClr val="accent1"/>
+                  <a:srgbClr val="6EC173"/>
                 </a:solidFill>
               </a:rPr>
               <a:t>실습</a:t>
@@ -5392,18 +5860,14 @@
             <a:r>
               <a:rPr lang="en-US" altLang="ko-KR" dirty="0">
                 <a:solidFill>
-                  <a:schemeClr val="accent1"/>
-                </a:solidFill>
-              </a:rPr>
-              <a:t>.</a:t>
-            </a:r>
-            <a:r>
-              <a:rPr lang="ko-KR" altLang="en-US" dirty="0">
-                <a:solidFill>
-                  <a:schemeClr val="accent1"/>
-                </a:solidFill>
-              </a:rPr>
-              <a:t> </a:t>
+                  <a:srgbClr val="6EC173"/>
+                </a:solidFill>
+              </a:rPr>
+              <a:t>.  </a:t>
+            </a:r>
+            <a:r>
+              <a:rPr lang="en-US" altLang="ko-KR" dirty="0"/>
+              <a:t> Java </a:t>
             </a:r>
             <a:r>
               <a:rPr lang="en-US" altLang="ko-KR" dirty="0" err="1"/>
@@ -5416,40 +5880,420 @@
           </a:p>
         </p:txBody>
       </p:sp>
-      <p:pic>
-        <p:nvPicPr>
-          <p:cNvPr id="7" name="그림 6">
-            <a:extLst>
-              <a:ext uri="{FF2B5EF4-FFF2-40B4-BE49-F238E27FC236}">
-                <a16:creationId xmlns:a16="http://schemas.microsoft.com/office/drawing/2014/main" id="{3BCC2596-B4B2-4917-BEA8-D01708F7A239}"/>
-              </a:ext>
-            </a:extLst>
-          </p:cNvPr>
-          <p:cNvPicPr>
-            <a:picLocks noChangeAspect="1"/>
-          </p:cNvPicPr>
+      <p:sp>
+        <p:nvSpPr>
+          <p:cNvPr id="6" name="내용 개체 틀 1">
+            <a:extLst>
+              <a:ext uri="{FF2B5EF4-FFF2-40B4-BE49-F238E27FC236}">
+                <a16:creationId xmlns:a16="http://schemas.microsoft.com/office/drawing/2014/main" id="{70C2BA37-BE91-39C4-AC08-0E8A1052E2F7}"/>
+              </a:ext>
+            </a:extLst>
+          </p:cNvPr>
+          <p:cNvSpPr txBox="1">
+            <a:spLocks/>
+          </p:cNvSpPr>
           <p:nvPr/>
-        </p:nvPicPr>
-        <p:blipFill>
-          <a:blip r:embed="rId2"/>
-          <a:stretch>
-            <a:fillRect/>
-          </a:stretch>
-        </p:blipFill>
+        </p:nvSpPr>
         <p:spPr>
           <a:xfrm>
-            <a:off x="4329331" y="3000691"/>
-            <a:ext cx="2466537" cy="3077616"/>
+            <a:off x="838200" y="1825625"/>
+            <a:ext cx="10515600" cy="4351338"/>
           </a:xfrm>
           <a:prstGeom prst="rect">
             <a:avLst/>
           </a:prstGeom>
         </p:spPr>
-      </p:pic>
+        <p:txBody>
+          <a:bodyPr vert="horz" lIns="91440" tIns="45720" rIns="91440" bIns="45720" rtlCol="0">
+            <a:normAutofit/>
+          </a:bodyPr>
+          <a:lstStyle>
+            <a:lvl1pPr marL="228600" indent="-228600" algn="l" defTabSz="914400" rtl="0" eaLnBrk="1" latinLnBrk="1" hangingPunct="1">
+              <a:lnSpc>
+                <a:spcPct val="90000"/>
+              </a:lnSpc>
+              <a:spcBef>
+                <a:spcPts val="1000"/>
+              </a:spcBef>
+              <a:buFont typeface="Arial" panose="020B0604020202020204" pitchFamily="34" charset="0"/>
+              <a:buChar char="•"/>
+              <a:defRPr sz="2800" kern="1200">
+                <a:solidFill>
+                  <a:schemeClr val="tx1"/>
+                </a:solidFill>
+                <a:latin typeface="+mn-lt"/>
+                <a:ea typeface="+mn-ea"/>
+                <a:cs typeface="+mn-cs"/>
+              </a:defRPr>
+            </a:lvl1pPr>
+            <a:lvl2pPr marL="685800" indent="-228600" algn="l" defTabSz="914400" rtl="0" eaLnBrk="1" latinLnBrk="1" hangingPunct="1">
+              <a:lnSpc>
+                <a:spcPct val="90000"/>
+              </a:lnSpc>
+              <a:spcBef>
+                <a:spcPts val="500"/>
+              </a:spcBef>
+              <a:buFont typeface="Arial" panose="020B0604020202020204" pitchFamily="34" charset="0"/>
+              <a:buChar char="•"/>
+              <a:defRPr sz="2400" kern="1200">
+                <a:solidFill>
+                  <a:schemeClr val="tx1"/>
+                </a:solidFill>
+                <a:latin typeface="+mn-lt"/>
+                <a:ea typeface="+mn-ea"/>
+                <a:cs typeface="+mn-cs"/>
+              </a:defRPr>
+            </a:lvl2pPr>
+            <a:lvl3pPr marL="1143000" indent="-228600" algn="l" defTabSz="914400" rtl="0" eaLnBrk="1" latinLnBrk="1" hangingPunct="1">
+              <a:lnSpc>
+                <a:spcPct val="90000"/>
+              </a:lnSpc>
+              <a:spcBef>
+                <a:spcPts val="500"/>
+              </a:spcBef>
+              <a:buFont typeface="Arial" panose="020B0604020202020204" pitchFamily="34" charset="0"/>
+              <a:buChar char="•"/>
+              <a:defRPr sz="2000" kern="1200">
+                <a:solidFill>
+                  <a:schemeClr val="tx1"/>
+                </a:solidFill>
+                <a:latin typeface="+mn-lt"/>
+                <a:ea typeface="+mn-ea"/>
+                <a:cs typeface="+mn-cs"/>
+              </a:defRPr>
+            </a:lvl3pPr>
+            <a:lvl4pPr marL="1600200" indent="-228600" algn="l" defTabSz="914400" rtl="0" eaLnBrk="1" latinLnBrk="1" hangingPunct="1">
+              <a:lnSpc>
+                <a:spcPct val="90000"/>
+              </a:lnSpc>
+              <a:spcBef>
+                <a:spcPts val="500"/>
+              </a:spcBef>
+              <a:buFont typeface="Arial" panose="020B0604020202020204" pitchFamily="34" charset="0"/>
+              <a:buChar char="•"/>
+              <a:defRPr sz="1800" kern="1200">
+                <a:solidFill>
+                  <a:schemeClr val="tx1"/>
+                </a:solidFill>
+                <a:latin typeface="+mn-lt"/>
+                <a:ea typeface="+mn-ea"/>
+                <a:cs typeface="+mn-cs"/>
+              </a:defRPr>
+            </a:lvl4pPr>
+            <a:lvl5pPr marL="2057400" indent="-228600" algn="l" defTabSz="914400" rtl="0" eaLnBrk="1" latinLnBrk="1" hangingPunct="1">
+              <a:lnSpc>
+                <a:spcPct val="90000"/>
+              </a:lnSpc>
+              <a:spcBef>
+                <a:spcPts val="500"/>
+              </a:spcBef>
+              <a:buFont typeface="Arial" panose="020B0604020202020204" pitchFamily="34" charset="0"/>
+              <a:buChar char="•"/>
+              <a:defRPr sz="1800" kern="1200">
+                <a:solidFill>
+                  <a:schemeClr val="tx1"/>
+                </a:solidFill>
+                <a:latin typeface="+mn-lt"/>
+                <a:ea typeface="+mn-ea"/>
+                <a:cs typeface="+mn-cs"/>
+              </a:defRPr>
+            </a:lvl5pPr>
+            <a:lvl6pPr marL="2514600" indent="-228600" algn="l" defTabSz="914400" rtl="0" eaLnBrk="1" latinLnBrk="1" hangingPunct="1">
+              <a:lnSpc>
+                <a:spcPct val="90000"/>
+              </a:lnSpc>
+              <a:spcBef>
+                <a:spcPts val="500"/>
+              </a:spcBef>
+              <a:buFont typeface="Arial" panose="020B0604020202020204" pitchFamily="34" charset="0"/>
+              <a:buChar char="•"/>
+              <a:defRPr sz="1800" kern="1200">
+                <a:solidFill>
+                  <a:schemeClr val="tx1"/>
+                </a:solidFill>
+                <a:latin typeface="+mn-lt"/>
+                <a:ea typeface="+mn-ea"/>
+                <a:cs typeface="+mn-cs"/>
+              </a:defRPr>
+            </a:lvl6pPr>
+            <a:lvl7pPr marL="2971800" indent="-228600" algn="l" defTabSz="914400" rtl="0" eaLnBrk="1" latinLnBrk="1" hangingPunct="1">
+              <a:lnSpc>
+                <a:spcPct val="90000"/>
+              </a:lnSpc>
+              <a:spcBef>
+                <a:spcPts val="500"/>
+              </a:spcBef>
+              <a:buFont typeface="Arial" panose="020B0604020202020204" pitchFamily="34" charset="0"/>
+              <a:buChar char="•"/>
+              <a:defRPr sz="1800" kern="1200">
+                <a:solidFill>
+                  <a:schemeClr val="tx1"/>
+                </a:solidFill>
+                <a:latin typeface="+mn-lt"/>
+                <a:ea typeface="+mn-ea"/>
+                <a:cs typeface="+mn-cs"/>
+              </a:defRPr>
+            </a:lvl7pPr>
+            <a:lvl8pPr marL="3429000" indent="-228600" algn="l" defTabSz="914400" rtl="0" eaLnBrk="1" latinLnBrk="1" hangingPunct="1">
+              <a:lnSpc>
+                <a:spcPct val="90000"/>
+              </a:lnSpc>
+              <a:spcBef>
+                <a:spcPts val="500"/>
+              </a:spcBef>
+              <a:buFont typeface="Arial" panose="020B0604020202020204" pitchFamily="34" charset="0"/>
+              <a:buChar char="•"/>
+              <a:defRPr sz="1800" kern="1200">
+                <a:solidFill>
+                  <a:schemeClr val="tx1"/>
+                </a:solidFill>
+                <a:latin typeface="+mn-lt"/>
+                <a:ea typeface="+mn-ea"/>
+                <a:cs typeface="+mn-cs"/>
+              </a:defRPr>
+            </a:lvl8pPr>
+            <a:lvl9pPr marL="3886200" indent="-228600" algn="l" defTabSz="914400" rtl="0" eaLnBrk="1" latinLnBrk="1" hangingPunct="1">
+              <a:lnSpc>
+                <a:spcPct val="90000"/>
+              </a:lnSpc>
+              <a:spcBef>
+                <a:spcPts val="500"/>
+              </a:spcBef>
+              <a:buFont typeface="Arial" panose="020B0604020202020204" pitchFamily="34" charset="0"/>
+              <a:buChar char="•"/>
+              <a:defRPr sz="1800" kern="1200">
+                <a:solidFill>
+                  <a:schemeClr val="tx1"/>
+                </a:solidFill>
+                <a:latin typeface="+mn-lt"/>
+                <a:ea typeface="+mn-ea"/>
+                <a:cs typeface="+mn-cs"/>
+              </a:defRPr>
+            </a:lvl9pPr>
+          </a:lstStyle>
+          <a:p>
+            <a:pPr marL="457200" lvl="1" indent="0">
+              <a:buFont typeface="Arial" panose="020B0604020202020204" pitchFamily="34" charset="0"/>
+              <a:buNone/>
+            </a:pPr>
+            <a:endParaRPr lang="en-US" altLang="ko-KR" dirty="0">
+              <a:solidFill>
+                <a:srgbClr val="212529"/>
+              </a:solidFill>
+              <a:latin typeface="+mn-ea"/>
+            </a:endParaRPr>
+          </a:p>
+          <a:p>
+            <a:pPr marL="457200" lvl="1" indent="0">
+              <a:buFont typeface="Arial" panose="020B0604020202020204" pitchFamily="34" charset="0"/>
+              <a:buNone/>
+            </a:pPr>
+            <a:endParaRPr lang="en-US" altLang="ko-KR" dirty="0">
+              <a:solidFill>
+                <a:srgbClr val="212529"/>
+              </a:solidFill>
+              <a:latin typeface="+mn-ea"/>
+            </a:endParaRPr>
+          </a:p>
+          <a:p>
+            <a:r>
+              <a:rPr lang="en-US" altLang="ko-KR" b="1" dirty="0">
+                <a:solidFill>
+                  <a:srgbClr val="212529"/>
+                </a:solidFill>
+                <a:latin typeface="+mn-ea"/>
+              </a:rPr>
+              <a:t>[</a:t>
+            </a:r>
+            <a:r>
+              <a:rPr lang="ko-KR" altLang="en-US" b="1" dirty="0" err="1">
+                <a:solidFill>
+                  <a:srgbClr val="212529"/>
+                </a:solidFill>
+                <a:latin typeface="+mn-ea"/>
+              </a:rPr>
+              <a:t>코딩온</a:t>
+            </a:r>
+            <a:r>
+              <a:rPr lang="en-US" altLang="ko-KR" b="1" dirty="0">
+                <a:solidFill>
+                  <a:srgbClr val="212529"/>
+                </a:solidFill>
+                <a:latin typeface="+mn-ea"/>
+              </a:rPr>
+              <a:t>] Java, Spring</a:t>
+            </a:r>
+            <a:r>
+              <a:rPr lang="ko-KR" altLang="en-US" b="1" dirty="0">
+                <a:solidFill>
+                  <a:srgbClr val="212529"/>
+                </a:solidFill>
+                <a:latin typeface="+mn-ea"/>
+              </a:rPr>
+              <a:t> </a:t>
+            </a:r>
+            <a:r>
+              <a:rPr lang="ko-KR" altLang="en-US" dirty="0">
+                <a:solidFill>
+                  <a:srgbClr val="212529"/>
+                </a:solidFill>
+                <a:latin typeface="+mn-ea"/>
+              </a:rPr>
+              <a:t>강의 클릭</a:t>
+            </a:r>
+            <a:br>
+              <a:rPr lang="en-US" altLang="ko-KR" dirty="0">
+                <a:solidFill>
+                  <a:srgbClr val="212529"/>
+                </a:solidFill>
+                <a:latin typeface="+mn-ea"/>
+              </a:rPr>
+            </a:br>
+            <a:endParaRPr lang="en-US" altLang="ko-KR" dirty="0">
+              <a:solidFill>
+                <a:srgbClr val="212529"/>
+              </a:solidFill>
+              <a:latin typeface="+mn-ea"/>
+            </a:endParaRPr>
+          </a:p>
+          <a:p>
+            <a:pPr lvl="1"/>
+            <a:r>
+              <a:rPr lang="ko-KR" altLang="en-US" sz="2800" b="1" dirty="0">
+                <a:solidFill>
+                  <a:srgbClr val="212529"/>
+                </a:solidFill>
+                <a:latin typeface="+mn-ea"/>
+              </a:rPr>
+              <a:t>➡ </a:t>
+            </a:r>
+            <a:r>
+              <a:rPr lang="en-US" altLang="ko-KR" sz="2800" b="1" dirty="0">
+                <a:solidFill>
+                  <a:srgbClr val="212529"/>
+                </a:solidFill>
+                <a:latin typeface="+mn-ea"/>
+              </a:rPr>
+              <a:t>[</a:t>
+            </a:r>
+            <a:r>
+              <a:rPr lang="en-US" altLang="ko-KR" sz="2800" b="1" dirty="0"/>
+              <a:t>Java </a:t>
+            </a:r>
+            <a:r>
+              <a:rPr lang="en-US" altLang="ko-KR" sz="2800" b="1" dirty="0" err="1"/>
+              <a:t>ArrayList</a:t>
+            </a:r>
+            <a:r>
+              <a:rPr lang="ko-KR" altLang="en-US" sz="2800" b="1" dirty="0"/>
+              <a:t> </a:t>
+            </a:r>
+            <a:r>
+              <a:rPr lang="ko-KR" altLang="en-US" sz="2800" b="1" dirty="0">
+                <a:solidFill>
+                  <a:srgbClr val="212529"/>
+                </a:solidFill>
+                <a:latin typeface="+mn-ea"/>
+              </a:rPr>
+              <a:t>실습</a:t>
+            </a:r>
+            <a:r>
+              <a:rPr lang="en-US" altLang="ko-KR" sz="2800" b="1" dirty="0">
+                <a:solidFill>
+                  <a:srgbClr val="212529"/>
+                </a:solidFill>
+                <a:latin typeface="+mn-ea"/>
+              </a:rPr>
+              <a:t>]</a:t>
+            </a:r>
+            <a:r>
+              <a:rPr lang="en-US" altLang="ko-KR" sz="2800" dirty="0">
+                <a:solidFill>
+                  <a:srgbClr val="212529"/>
+                </a:solidFill>
+                <a:latin typeface="+mn-ea"/>
+              </a:rPr>
+              <a:t> </a:t>
+            </a:r>
+            <a:r>
+              <a:rPr lang="ko-KR" altLang="en-US" sz="2800" dirty="0">
+                <a:solidFill>
+                  <a:srgbClr val="212529"/>
+                </a:solidFill>
+                <a:latin typeface="+mn-ea"/>
+              </a:rPr>
+              <a:t>커리큘럼 클릭</a:t>
+            </a:r>
+            <a:endParaRPr lang="en-US" altLang="ko-KR" sz="2800" dirty="0">
+              <a:solidFill>
+                <a:srgbClr val="212529"/>
+              </a:solidFill>
+              <a:latin typeface="+mn-ea"/>
+            </a:endParaRPr>
+          </a:p>
+          <a:p>
+            <a:pPr lvl="1"/>
+            <a:r>
+              <a:rPr lang="ko-KR" altLang="en-US" sz="2800" b="1" dirty="0">
+                <a:solidFill>
+                  <a:srgbClr val="212529"/>
+                </a:solidFill>
+                <a:latin typeface="+mn-ea"/>
+              </a:rPr>
+              <a:t>➡ </a:t>
+            </a:r>
+            <a:r>
+              <a:rPr lang="en-US" altLang="ko-KR" sz="2800" b="1" dirty="0">
+                <a:solidFill>
+                  <a:schemeClr val="accent1"/>
+                </a:solidFill>
+                <a:latin typeface="+mn-ea"/>
+              </a:rPr>
+              <a:t>[1</a:t>
+            </a:r>
+            <a:r>
+              <a:rPr lang="ko-KR" altLang="en-US" sz="2800" b="1" dirty="0">
+                <a:solidFill>
+                  <a:schemeClr val="accent1"/>
+                </a:solidFill>
+                <a:latin typeface="+mn-ea"/>
+              </a:rPr>
+              <a:t>번 문제</a:t>
+            </a:r>
+            <a:r>
+              <a:rPr lang="en-US" altLang="ko-KR" sz="2800" b="1" dirty="0">
+                <a:solidFill>
+                  <a:schemeClr val="accent1"/>
+                </a:solidFill>
+                <a:latin typeface="+mn-ea"/>
+              </a:rPr>
+              <a:t>]</a:t>
+            </a:r>
+            <a:r>
+              <a:rPr lang="en-US" altLang="ko-KR" sz="2800" dirty="0">
+                <a:solidFill>
+                  <a:schemeClr val="accent1"/>
+                </a:solidFill>
+                <a:latin typeface="+mn-ea"/>
+              </a:rPr>
+              <a:t> </a:t>
+            </a:r>
+            <a:r>
+              <a:rPr lang="ko-KR" altLang="en-US" sz="2800" dirty="0">
+                <a:solidFill>
+                  <a:srgbClr val="212529"/>
+                </a:solidFill>
+                <a:latin typeface="+mn-ea"/>
+              </a:rPr>
+              <a:t> 진행</a:t>
+            </a:r>
+          </a:p>
+        </p:txBody>
+      </p:sp>
     </p:spTree>
     <p:extLst>
       <p:ext uri="{BB962C8B-B14F-4D97-AF65-F5344CB8AC3E}">
-        <p14:creationId xmlns:p14="http://schemas.microsoft.com/office/powerpoint/2010/main" val="1650522474"/>
+        <p14:creationId xmlns:p14="http://schemas.microsoft.com/office/powerpoint/2010/main" val="1854209745"/>
       </p:ext>
     </p:extLst>
   </p:cSld>
@@ -5493,7 +6337,7 @@
           <a:p>
             <a:fld id="{0E19CB95-6D28-40F1-9DA3-1BAC5D4B5B4F}" type="datetime6">
               <a:rPr lang="ko-KR" altLang="en-US" smtClean="0"/>
-              <a:t>2024년 7월</a:t>
+              <a:t>2024년 9월</a:t>
             </a:fld>
             <a:endParaRPr lang="ko-KR" altLang="en-US"/>
           </a:p>
@@ -5655,7 +6499,7 @@
           <a:p>
             <a:fld id="{CE27A22C-65A3-484B-AF1E-9F8BD90A2FC7}" type="datetime1">
               <a:rPr lang="ko-KR" altLang="en-US" smtClean="0"/>
-              <a:t>2024-07-05</a:t>
+              <a:t>2024-09-23</a:t>
             </a:fld>
             <a:endParaRPr lang="ko-KR" altLang="en-US"/>
           </a:p>
@@ -5835,7 +6679,7 @@
           <a:p>
             <a:fld id="{CE27A22C-65A3-484B-AF1E-9F8BD90A2FC7}" type="datetime1">
               <a:rPr lang="ko-KR" altLang="en-US" smtClean="0"/>
-              <a:t>2024-07-05</a:t>
+              <a:t>2024-09-23</a:t>
             </a:fld>
             <a:endParaRPr lang="ko-KR" altLang="en-US"/>
           </a:p>
@@ -6049,7 +6893,7 @@
           <a:p>
             <a:fld id="{CE27A22C-65A3-484B-AF1E-9F8BD90A2FC7}" type="datetime1">
               <a:rPr lang="ko-KR" altLang="en-US" smtClean="0"/>
-              <a:t>2024-07-05</a:t>
+              <a:t>2024-09-23</a:t>
             </a:fld>
             <a:endParaRPr lang="ko-KR" altLang="en-US"/>
           </a:p>
@@ -6225,7 +7069,7 @@
           <a:p>
             <a:fld id="{CE27A22C-65A3-484B-AF1E-9F8BD90A2FC7}" type="datetime1">
               <a:rPr lang="ko-KR" altLang="en-US" smtClean="0"/>
-              <a:t>2024-07-05</a:t>
+              <a:t>2024-09-23</a:t>
             </a:fld>
             <a:endParaRPr lang="ko-KR" altLang="en-US"/>
           </a:p>
@@ -6413,7 +7257,7 @@
           <a:p>
             <a:fld id="{CE27A22C-65A3-484B-AF1E-9F8BD90A2FC7}" type="datetime1">
               <a:rPr lang="ko-KR" altLang="en-US" smtClean="0"/>
-              <a:t>2024-07-05</a:t>
+              <a:t>2024-09-23</a:t>
             </a:fld>
             <a:endParaRPr lang="ko-KR" altLang="en-US"/>
           </a:p>
@@ -6542,10 +7386,10 @@
       </p:grpSpPr>
       <p:sp>
         <p:nvSpPr>
-          <p:cNvPr id="3" name="내용 개체 틀 2">
-            <a:extLst>
-              <a:ext uri="{FF2B5EF4-FFF2-40B4-BE49-F238E27FC236}">
-                <a16:creationId xmlns:a16="http://schemas.microsoft.com/office/drawing/2014/main" id="{48F1F3A4-1C34-E0EC-1365-0360299807D6}"/>
+          <p:cNvPr id="13" name="내용 개체 틀 2">
+            <a:extLst>
+              <a:ext uri="{FF2B5EF4-FFF2-40B4-BE49-F238E27FC236}">
+                <a16:creationId xmlns:a16="http://schemas.microsoft.com/office/drawing/2014/main" id="{847FD532-7F61-A001-537F-B970BD821AF3}"/>
               </a:ext>
             </a:extLst>
           </p:cNvPr>
@@ -6558,8 +7402,8 @@
         </p:nvSpPr>
         <p:spPr>
           <a:xfrm>
-            <a:off x="838200" y="1565213"/>
-            <a:ext cx="10826262" cy="4111688"/>
+            <a:off x="510988" y="1328391"/>
+            <a:ext cx="11260802" cy="5328442"/>
           </a:xfrm>
         </p:spPr>
         <p:txBody>
@@ -6568,74 +7412,19 @@
           </a:bodyPr>
           <a:lstStyle/>
           <a:p>
-            <a:r>
-              <a:rPr lang="ko-KR" altLang="en-US" sz="2400" dirty="0"/>
-              <a:t>숫자 </a:t>
-            </a:r>
-            <a:r>
-              <a:rPr lang="en-US" altLang="ko-KR" sz="2400" dirty="0"/>
-              <a:t>5</a:t>
-            </a:r>
-            <a:r>
-              <a:rPr lang="ko-KR" altLang="en-US" sz="2400" dirty="0"/>
-              <a:t>개의 정수를 입력 받아</a:t>
-            </a:r>
-            <a:r>
-              <a:rPr lang="en-US" altLang="ko-KR" sz="2400" dirty="0"/>
-              <a:t>, </a:t>
-            </a:r>
-            <a:r>
-              <a:rPr lang="ko-KR" altLang="en-US" sz="2400" dirty="0"/>
-              <a:t>평균을 구하는 프로그램을 작성해주세요</a:t>
-            </a:r>
-            <a:r>
-              <a:rPr lang="en-US" altLang="ko-KR" sz="2400" dirty="0"/>
-              <a:t>.</a:t>
-            </a:r>
+            <a:endParaRPr lang="en-US" altLang="ko-KR" dirty="0"/>
           </a:p>
           <a:p>
             <a:pPr marL="0" indent="0">
               <a:buNone/>
             </a:pPr>
-            <a:endParaRPr lang="en-US" altLang="ko-KR" sz="2400" dirty="0"/>
+            <a:endParaRPr lang="en-US" altLang="ko-KR" dirty="0"/>
           </a:p>
           <a:p>
             <a:pPr marL="0" indent="0">
               <a:buNone/>
             </a:pPr>
-            <a:endParaRPr lang="en-US" altLang="ko-KR" sz="2400" dirty="0"/>
-          </a:p>
-          <a:p>
-            <a:pPr marL="0" indent="0">
-              <a:buNone/>
-            </a:pPr>
-            <a:r>
-              <a:rPr lang="ko-KR" altLang="en-US" sz="2400" dirty="0">
-                <a:solidFill>
-                  <a:schemeClr val="accent1"/>
-                </a:solidFill>
-              </a:rPr>
-              <a:t>힌트</a:t>
-            </a:r>
-            <a:r>
-              <a:rPr lang="en-US" altLang="ko-KR" sz="2400" dirty="0">
-                <a:solidFill>
-                  <a:schemeClr val="accent1"/>
-                </a:solidFill>
-              </a:rPr>
-              <a:t>! </a:t>
-            </a:r>
-            <a:r>
-              <a:rPr lang="ko-KR" altLang="en-US" sz="2400" dirty="0"/>
-              <a:t>강제 형 변환</a:t>
-            </a:r>
-            <a:endParaRPr lang="en-US" altLang="ko-KR" sz="2400" dirty="0"/>
-          </a:p>
-          <a:p>
-            <a:pPr marL="0" indent="0">
-              <a:buNone/>
-            </a:pPr>
-            <a:endParaRPr lang="ko-KR" altLang="en-US" sz="2400" dirty="0"/>
+            <a:endParaRPr lang="en-US" altLang="ko-KR" dirty="0"/>
           </a:p>
         </p:txBody>
       </p:sp>
@@ -6644,7 +7433,7 @@
           <p:cNvPr id="4" name="날짜 개체 틀 3">
             <a:extLst>
               <a:ext uri="{FF2B5EF4-FFF2-40B4-BE49-F238E27FC236}">
-                <a16:creationId xmlns:a16="http://schemas.microsoft.com/office/drawing/2014/main" id="{D269450B-7D34-7D80-C05E-003E1A5F0D3D}"/>
+                <a16:creationId xmlns:a16="http://schemas.microsoft.com/office/drawing/2014/main" id="{A695DDE5-0A39-A366-4CFE-A283911999CD}"/>
               </a:ext>
             </a:extLst>
           </p:cNvPr>
@@ -6660,11 +7449,11 @@
           <a:bodyPr/>
           <a:lstStyle/>
           <a:p>
-            <a:fld id="{CE27A22C-65A3-484B-AF1E-9F8BD90A2FC7}" type="datetime1">
+            <a:fld id="{0F78D9C4-20C1-4B15-A116-16DC77AD9A1E}" type="datetime1">
               <a:rPr lang="ko-KR" altLang="en-US" smtClean="0"/>
-              <a:t>2024-07-05</a:t>
+              <a:t>2024-09-23</a:t>
             </a:fld>
-            <a:endParaRPr lang="ko-KR" altLang="en-US" dirty="0"/>
+            <a:endParaRPr lang="ko-KR" altLang="en-US"/>
           </a:p>
         </p:txBody>
       </p:sp>
@@ -6673,7 +7462,7 @@
           <p:cNvPr id="5" name="슬라이드 번호 개체 틀 4">
             <a:extLst>
               <a:ext uri="{FF2B5EF4-FFF2-40B4-BE49-F238E27FC236}">
-                <a16:creationId xmlns:a16="http://schemas.microsoft.com/office/drawing/2014/main" id="{89835C10-39B1-7735-B792-5881B339B742}"/>
+                <a16:creationId xmlns:a16="http://schemas.microsoft.com/office/drawing/2014/main" id="{5E040F43-60A7-C50D-1F5B-F984054F2D7C}"/>
               </a:ext>
             </a:extLst>
           </p:cNvPr>
@@ -6699,10 +7488,10 @@
       </p:sp>
       <p:sp>
         <p:nvSpPr>
-          <p:cNvPr id="6" name="제목 1">
-            <a:extLst>
-              <a:ext uri="{FF2B5EF4-FFF2-40B4-BE49-F238E27FC236}">
-                <a16:creationId xmlns:a16="http://schemas.microsoft.com/office/drawing/2014/main" id="{8657E4F7-9B60-A2D7-860C-6BE8D7D70F07}"/>
+          <p:cNvPr id="2" name="제목 1">
+            <a:extLst>
+              <a:ext uri="{FF2B5EF4-FFF2-40B4-BE49-F238E27FC236}">
+                <a16:creationId xmlns:a16="http://schemas.microsoft.com/office/drawing/2014/main" id="{5FAC57F5-99D7-9C46-B6C1-D16224151FE9}"/>
               </a:ext>
             </a:extLst>
           </p:cNvPr>
@@ -6721,7 +7510,7 @@
             <a:r>
               <a:rPr lang="ko-KR" altLang="en-US" dirty="0">
                 <a:solidFill>
-                  <a:schemeClr val="accent1"/>
+                  <a:srgbClr val="6EC173"/>
                 </a:solidFill>
               </a:rPr>
               <a:t>실습</a:t>
@@ -6729,18 +7518,14 @@
             <a:r>
               <a:rPr lang="en-US" altLang="ko-KR" dirty="0">
                 <a:solidFill>
-                  <a:schemeClr val="accent1"/>
-                </a:solidFill>
-              </a:rPr>
-              <a:t>.</a:t>
-            </a:r>
-            <a:r>
-              <a:rPr lang="ko-KR" altLang="en-US" dirty="0">
-                <a:solidFill>
-                  <a:schemeClr val="accent1"/>
-                </a:solidFill>
-              </a:rPr>
-              <a:t> </a:t>
+                  <a:srgbClr val="6EC173"/>
+                </a:solidFill>
+              </a:rPr>
+              <a:t>.  </a:t>
+            </a:r>
+            <a:r>
+              <a:rPr lang="en-US" altLang="ko-KR" dirty="0"/>
+              <a:t> Java </a:t>
             </a:r>
             <a:r>
               <a:rPr lang="ko-KR" altLang="en-US" dirty="0"/>
@@ -6749,141 +7534,416 @@
           </a:p>
         </p:txBody>
       </p:sp>
-      <p:pic>
-        <p:nvPicPr>
-          <p:cNvPr id="7" name="그림 6">
-            <a:extLst>
-              <a:ext uri="{FF2B5EF4-FFF2-40B4-BE49-F238E27FC236}">
-                <a16:creationId xmlns:a16="http://schemas.microsoft.com/office/drawing/2014/main" id="{B617EFEF-AC21-498F-7E88-78923BBDDDD3}"/>
-              </a:ext>
-            </a:extLst>
-          </p:cNvPr>
-          <p:cNvPicPr>
-            <a:picLocks noChangeAspect="1"/>
-          </p:cNvPicPr>
+      <p:sp>
+        <p:nvSpPr>
+          <p:cNvPr id="6" name="내용 개체 틀 1">
+            <a:extLst>
+              <a:ext uri="{FF2B5EF4-FFF2-40B4-BE49-F238E27FC236}">
+                <a16:creationId xmlns:a16="http://schemas.microsoft.com/office/drawing/2014/main" id="{70C2BA37-BE91-39C4-AC08-0E8A1052E2F7}"/>
+              </a:ext>
+            </a:extLst>
+          </p:cNvPr>
+          <p:cNvSpPr txBox="1">
+            <a:spLocks/>
+          </p:cNvSpPr>
           <p:nvPr/>
-        </p:nvPicPr>
-        <p:blipFill rotWithShape="1">
-          <a:blip r:embed="rId2"/>
-          <a:srcRect l="6408" t="10254"/>
-          <a:stretch/>
-        </p:blipFill>
+        </p:nvSpPr>
         <p:spPr>
           <a:xfrm>
-            <a:off x="6609315" y="2980173"/>
-            <a:ext cx="4412011" cy="1677998"/>
+            <a:off x="838200" y="1825625"/>
+            <a:ext cx="10515600" cy="4351338"/>
           </a:xfrm>
           <a:prstGeom prst="rect">
             <a:avLst/>
           </a:prstGeom>
         </p:spPr>
-      </p:pic>
-      <p:pic>
-        <p:nvPicPr>
-          <p:cNvPr id="9" name="그림 8">
-            <a:extLst>
-              <a:ext uri="{FF2B5EF4-FFF2-40B4-BE49-F238E27FC236}">
-                <a16:creationId xmlns:a16="http://schemas.microsoft.com/office/drawing/2014/main" id="{32B3CC33-BF05-15DA-CE2F-2F8F1C863AE8}"/>
-              </a:ext>
-            </a:extLst>
-          </p:cNvPr>
-          <p:cNvPicPr>
-            <a:picLocks noChangeAspect="1"/>
-          </p:cNvPicPr>
-          <p:nvPr/>
-        </p:nvPicPr>
-        <p:blipFill>
-          <a:blip r:embed="rId3"/>
-          <a:stretch>
-            <a:fillRect/>
-          </a:stretch>
-        </p:blipFill>
-        <p:spPr>
-          <a:xfrm>
-            <a:off x="838200" y="3429000"/>
-            <a:ext cx="5127980" cy="780345"/>
-          </a:xfrm>
-          <a:prstGeom prst="rect">
-            <a:avLst/>
-          </a:prstGeom>
-        </p:spPr>
-      </p:pic>
-      <p:pic>
-        <p:nvPicPr>
-          <p:cNvPr id="11" name="그림 10">
-            <a:extLst>
-              <a:ext uri="{FF2B5EF4-FFF2-40B4-BE49-F238E27FC236}">
-                <a16:creationId xmlns:a16="http://schemas.microsoft.com/office/drawing/2014/main" id="{B3082412-2DD5-A1F9-7D19-0CF8FAC67B7F}"/>
-              </a:ext>
-            </a:extLst>
-          </p:cNvPr>
-          <p:cNvPicPr>
-            <a:picLocks noChangeAspect="1"/>
-          </p:cNvPicPr>
-          <p:nvPr/>
-        </p:nvPicPr>
-        <p:blipFill>
-          <a:blip r:embed="rId4"/>
-          <a:stretch>
-            <a:fillRect/>
-          </a:stretch>
-        </p:blipFill>
-        <p:spPr>
-          <a:xfrm>
-            <a:off x="2516827" y="4778213"/>
-            <a:ext cx="1086266" cy="818419"/>
-          </a:xfrm>
-          <a:prstGeom prst="rect">
-            <a:avLst/>
-          </a:prstGeom>
-        </p:spPr>
-      </p:pic>
-      <p:cxnSp>
-        <p:nvCxnSpPr>
-          <p:cNvPr id="13" name="직선 화살표 연결선 12">
-            <a:extLst>
-              <a:ext uri="{FF2B5EF4-FFF2-40B4-BE49-F238E27FC236}">
-                <a16:creationId xmlns:a16="http://schemas.microsoft.com/office/drawing/2014/main" id="{8C6E2875-7134-F434-52A4-B517DF304A41}"/>
-              </a:ext>
-            </a:extLst>
-          </p:cNvPr>
-          <p:cNvCxnSpPr/>
-          <p:nvPr/>
-        </p:nvCxnSpPr>
-        <p:spPr>
-          <a:xfrm>
-            <a:off x="3172896" y="4291410"/>
-            <a:ext cx="0" cy="406534"/>
-          </a:xfrm>
-          <a:prstGeom prst="straightConnector1">
-            <a:avLst/>
-          </a:prstGeom>
-          <a:ln w="57150">
-            <a:solidFill>
-              <a:srgbClr val="FF0000"/>
-            </a:solidFill>
-            <a:tailEnd type="triangle"/>
-          </a:ln>
-        </p:spPr>
-        <p:style>
-          <a:lnRef idx="1">
-            <a:schemeClr val="accent1"/>
-          </a:lnRef>
-          <a:fillRef idx="0">
-            <a:schemeClr val="accent1"/>
-          </a:fillRef>
-          <a:effectRef idx="0">
-            <a:schemeClr val="accent1"/>
-          </a:effectRef>
-          <a:fontRef idx="minor">
-            <a:schemeClr val="tx1"/>
-          </a:fontRef>
-        </p:style>
-      </p:cxnSp>
+        <p:txBody>
+          <a:bodyPr vert="horz" lIns="91440" tIns="45720" rIns="91440" bIns="45720" rtlCol="0">
+            <a:normAutofit/>
+          </a:bodyPr>
+          <a:lstStyle>
+            <a:lvl1pPr marL="228600" indent="-228600" algn="l" defTabSz="914400" rtl="0" eaLnBrk="1" latinLnBrk="1" hangingPunct="1">
+              <a:lnSpc>
+                <a:spcPct val="90000"/>
+              </a:lnSpc>
+              <a:spcBef>
+                <a:spcPts val="1000"/>
+              </a:spcBef>
+              <a:buFont typeface="Arial" panose="020B0604020202020204" pitchFamily="34" charset="0"/>
+              <a:buChar char="•"/>
+              <a:defRPr sz="2800" kern="1200">
+                <a:solidFill>
+                  <a:schemeClr val="tx1"/>
+                </a:solidFill>
+                <a:latin typeface="+mn-lt"/>
+                <a:ea typeface="+mn-ea"/>
+                <a:cs typeface="+mn-cs"/>
+              </a:defRPr>
+            </a:lvl1pPr>
+            <a:lvl2pPr marL="685800" indent="-228600" algn="l" defTabSz="914400" rtl="0" eaLnBrk="1" latinLnBrk="1" hangingPunct="1">
+              <a:lnSpc>
+                <a:spcPct val="90000"/>
+              </a:lnSpc>
+              <a:spcBef>
+                <a:spcPts val="500"/>
+              </a:spcBef>
+              <a:buFont typeface="Arial" panose="020B0604020202020204" pitchFamily="34" charset="0"/>
+              <a:buChar char="•"/>
+              <a:defRPr sz="2400" kern="1200">
+                <a:solidFill>
+                  <a:schemeClr val="tx1"/>
+                </a:solidFill>
+                <a:latin typeface="+mn-lt"/>
+                <a:ea typeface="+mn-ea"/>
+                <a:cs typeface="+mn-cs"/>
+              </a:defRPr>
+            </a:lvl2pPr>
+            <a:lvl3pPr marL="1143000" indent="-228600" algn="l" defTabSz="914400" rtl="0" eaLnBrk="1" latinLnBrk="1" hangingPunct="1">
+              <a:lnSpc>
+                <a:spcPct val="90000"/>
+              </a:lnSpc>
+              <a:spcBef>
+                <a:spcPts val="500"/>
+              </a:spcBef>
+              <a:buFont typeface="Arial" panose="020B0604020202020204" pitchFamily="34" charset="0"/>
+              <a:buChar char="•"/>
+              <a:defRPr sz="2000" kern="1200">
+                <a:solidFill>
+                  <a:schemeClr val="tx1"/>
+                </a:solidFill>
+                <a:latin typeface="+mn-lt"/>
+                <a:ea typeface="+mn-ea"/>
+                <a:cs typeface="+mn-cs"/>
+              </a:defRPr>
+            </a:lvl3pPr>
+            <a:lvl4pPr marL="1600200" indent="-228600" algn="l" defTabSz="914400" rtl="0" eaLnBrk="1" latinLnBrk="1" hangingPunct="1">
+              <a:lnSpc>
+                <a:spcPct val="90000"/>
+              </a:lnSpc>
+              <a:spcBef>
+                <a:spcPts val="500"/>
+              </a:spcBef>
+              <a:buFont typeface="Arial" panose="020B0604020202020204" pitchFamily="34" charset="0"/>
+              <a:buChar char="•"/>
+              <a:defRPr sz="1800" kern="1200">
+                <a:solidFill>
+                  <a:schemeClr val="tx1"/>
+                </a:solidFill>
+                <a:latin typeface="+mn-lt"/>
+                <a:ea typeface="+mn-ea"/>
+                <a:cs typeface="+mn-cs"/>
+              </a:defRPr>
+            </a:lvl4pPr>
+            <a:lvl5pPr marL="2057400" indent="-228600" algn="l" defTabSz="914400" rtl="0" eaLnBrk="1" latinLnBrk="1" hangingPunct="1">
+              <a:lnSpc>
+                <a:spcPct val="90000"/>
+              </a:lnSpc>
+              <a:spcBef>
+                <a:spcPts val="500"/>
+              </a:spcBef>
+              <a:buFont typeface="Arial" panose="020B0604020202020204" pitchFamily="34" charset="0"/>
+              <a:buChar char="•"/>
+              <a:defRPr sz="1800" kern="1200">
+                <a:solidFill>
+                  <a:schemeClr val="tx1"/>
+                </a:solidFill>
+                <a:latin typeface="+mn-lt"/>
+                <a:ea typeface="+mn-ea"/>
+                <a:cs typeface="+mn-cs"/>
+              </a:defRPr>
+            </a:lvl5pPr>
+            <a:lvl6pPr marL="2514600" indent="-228600" algn="l" defTabSz="914400" rtl="0" eaLnBrk="1" latinLnBrk="1" hangingPunct="1">
+              <a:lnSpc>
+                <a:spcPct val="90000"/>
+              </a:lnSpc>
+              <a:spcBef>
+                <a:spcPts val="500"/>
+              </a:spcBef>
+              <a:buFont typeface="Arial" panose="020B0604020202020204" pitchFamily="34" charset="0"/>
+              <a:buChar char="•"/>
+              <a:defRPr sz="1800" kern="1200">
+                <a:solidFill>
+                  <a:schemeClr val="tx1"/>
+                </a:solidFill>
+                <a:latin typeface="+mn-lt"/>
+                <a:ea typeface="+mn-ea"/>
+                <a:cs typeface="+mn-cs"/>
+              </a:defRPr>
+            </a:lvl6pPr>
+            <a:lvl7pPr marL="2971800" indent="-228600" algn="l" defTabSz="914400" rtl="0" eaLnBrk="1" latinLnBrk="1" hangingPunct="1">
+              <a:lnSpc>
+                <a:spcPct val="90000"/>
+              </a:lnSpc>
+              <a:spcBef>
+                <a:spcPts val="500"/>
+              </a:spcBef>
+              <a:buFont typeface="Arial" panose="020B0604020202020204" pitchFamily="34" charset="0"/>
+              <a:buChar char="•"/>
+              <a:defRPr sz="1800" kern="1200">
+                <a:solidFill>
+                  <a:schemeClr val="tx1"/>
+                </a:solidFill>
+                <a:latin typeface="+mn-lt"/>
+                <a:ea typeface="+mn-ea"/>
+                <a:cs typeface="+mn-cs"/>
+              </a:defRPr>
+            </a:lvl7pPr>
+            <a:lvl8pPr marL="3429000" indent="-228600" algn="l" defTabSz="914400" rtl="0" eaLnBrk="1" latinLnBrk="1" hangingPunct="1">
+              <a:lnSpc>
+                <a:spcPct val="90000"/>
+              </a:lnSpc>
+              <a:spcBef>
+                <a:spcPts val="500"/>
+              </a:spcBef>
+              <a:buFont typeface="Arial" panose="020B0604020202020204" pitchFamily="34" charset="0"/>
+              <a:buChar char="•"/>
+              <a:defRPr sz="1800" kern="1200">
+                <a:solidFill>
+                  <a:schemeClr val="tx1"/>
+                </a:solidFill>
+                <a:latin typeface="+mn-lt"/>
+                <a:ea typeface="+mn-ea"/>
+                <a:cs typeface="+mn-cs"/>
+              </a:defRPr>
+            </a:lvl8pPr>
+            <a:lvl9pPr marL="3886200" indent="-228600" algn="l" defTabSz="914400" rtl="0" eaLnBrk="1" latinLnBrk="1" hangingPunct="1">
+              <a:lnSpc>
+                <a:spcPct val="90000"/>
+              </a:lnSpc>
+              <a:spcBef>
+                <a:spcPts val="500"/>
+              </a:spcBef>
+              <a:buFont typeface="Arial" panose="020B0604020202020204" pitchFamily="34" charset="0"/>
+              <a:buChar char="•"/>
+              <a:defRPr sz="1800" kern="1200">
+                <a:solidFill>
+                  <a:schemeClr val="tx1"/>
+                </a:solidFill>
+                <a:latin typeface="+mn-lt"/>
+                <a:ea typeface="+mn-ea"/>
+                <a:cs typeface="+mn-cs"/>
+              </a:defRPr>
+            </a:lvl9pPr>
+          </a:lstStyle>
+          <a:p>
+            <a:pPr marL="457200" lvl="1" indent="0">
+              <a:buFont typeface="Arial" panose="020B0604020202020204" pitchFamily="34" charset="0"/>
+              <a:buNone/>
+            </a:pPr>
+            <a:endParaRPr lang="en-US" altLang="ko-KR" dirty="0">
+              <a:solidFill>
+                <a:srgbClr val="212529"/>
+              </a:solidFill>
+              <a:latin typeface="+mn-ea"/>
+            </a:endParaRPr>
+          </a:p>
+          <a:p>
+            <a:pPr marL="457200" lvl="1" indent="0">
+              <a:buFont typeface="Arial" panose="020B0604020202020204" pitchFamily="34" charset="0"/>
+              <a:buNone/>
+            </a:pPr>
+            <a:endParaRPr lang="en-US" altLang="ko-KR" dirty="0">
+              <a:solidFill>
+                <a:srgbClr val="212529"/>
+              </a:solidFill>
+              <a:latin typeface="+mn-ea"/>
+            </a:endParaRPr>
+          </a:p>
+          <a:p>
+            <a:r>
+              <a:rPr lang="en-US" altLang="ko-KR" b="1" dirty="0">
+                <a:solidFill>
+                  <a:srgbClr val="212529"/>
+                </a:solidFill>
+                <a:latin typeface="+mn-ea"/>
+              </a:rPr>
+              <a:t>[</a:t>
+            </a:r>
+            <a:r>
+              <a:rPr lang="ko-KR" altLang="en-US" b="1" dirty="0" err="1">
+                <a:solidFill>
+                  <a:srgbClr val="212529"/>
+                </a:solidFill>
+                <a:latin typeface="+mn-ea"/>
+              </a:rPr>
+              <a:t>코딩온</a:t>
+            </a:r>
+            <a:r>
+              <a:rPr lang="en-US" altLang="ko-KR" b="1" dirty="0">
+                <a:solidFill>
+                  <a:srgbClr val="212529"/>
+                </a:solidFill>
+                <a:latin typeface="+mn-ea"/>
+              </a:rPr>
+              <a:t>] Java, Spring</a:t>
+            </a:r>
+            <a:r>
+              <a:rPr lang="ko-KR" altLang="en-US" b="1" dirty="0">
+                <a:solidFill>
+                  <a:srgbClr val="212529"/>
+                </a:solidFill>
+                <a:latin typeface="+mn-ea"/>
+              </a:rPr>
+              <a:t> </a:t>
+            </a:r>
+            <a:r>
+              <a:rPr lang="ko-KR" altLang="en-US" dirty="0">
+                <a:solidFill>
+                  <a:srgbClr val="212529"/>
+                </a:solidFill>
+                <a:latin typeface="+mn-ea"/>
+              </a:rPr>
+              <a:t>강의 클릭</a:t>
+            </a:r>
+            <a:br>
+              <a:rPr lang="en-US" altLang="ko-KR" dirty="0">
+                <a:solidFill>
+                  <a:srgbClr val="212529"/>
+                </a:solidFill>
+                <a:latin typeface="+mn-ea"/>
+              </a:rPr>
+            </a:br>
+            <a:endParaRPr lang="en-US" altLang="ko-KR" dirty="0">
+              <a:solidFill>
+                <a:srgbClr val="212529"/>
+              </a:solidFill>
+              <a:latin typeface="+mn-ea"/>
+            </a:endParaRPr>
+          </a:p>
+          <a:p>
+            <a:pPr lvl="1"/>
+            <a:r>
+              <a:rPr lang="ko-KR" altLang="en-US" sz="2800" b="1" dirty="0">
+                <a:solidFill>
+                  <a:srgbClr val="212529"/>
+                </a:solidFill>
+                <a:latin typeface="+mn-ea"/>
+              </a:rPr>
+              <a:t>➡ </a:t>
+            </a:r>
+            <a:r>
+              <a:rPr lang="en-US" altLang="ko-KR" sz="2800" b="1" dirty="0">
+                <a:solidFill>
+                  <a:srgbClr val="212529"/>
+                </a:solidFill>
+                <a:latin typeface="+mn-ea"/>
+              </a:rPr>
+              <a:t>[</a:t>
+            </a:r>
+            <a:r>
+              <a:rPr lang="en-US" altLang="ko-KR" sz="2800" b="1" dirty="0"/>
+              <a:t>Java </a:t>
+            </a:r>
+            <a:r>
+              <a:rPr lang="ko-KR" altLang="en-US" sz="2800" b="1" dirty="0"/>
+              <a:t>배열 </a:t>
+            </a:r>
+            <a:r>
+              <a:rPr lang="ko-KR" altLang="en-US" sz="2800" b="1" dirty="0">
+                <a:solidFill>
+                  <a:srgbClr val="212529"/>
+                </a:solidFill>
+                <a:latin typeface="+mn-ea"/>
+              </a:rPr>
+              <a:t>실습</a:t>
+            </a:r>
+            <a:r>
+              <a:rPr lang="en-US" altLang="ko-KR" sz="2800" b="1" dirty="0">
+                <a:solidFill>
+                  <a:srgbClr val="212529"/>
+                </a:solidFill>
+                <a:latin typeface="+mn-ea"/>
+              </a:rPr>
+              <a:t>]</a:t>
+            </a:r>
+            <a:r>
+              <a:rPr lang="en-US" altLang="ko-KR" sz="2800" dirty="0">
+                <a:solidFill>
+                  <a:srgbClr val="212529"/>
+                </a:solidFill>
+                <a:latin typeface="+mn-ea"/>
+              </a:rPr>
+              <a:t> </a:t>
+            </a:r>
+            <a:r>
+              <a:rPr lang="ko-KR" altLang="en-US" sz="2800" dirty="0">
+                <a:solidFill>
+                  <a:srgbClr val="212529"/>
+                </a:solidFill>
+                <a:latin typeface="+mn-ea"/>
+              </a:rPr>
+              <a:t>커리큘럼 클릭</a:t>
+            </a:r>
+            <a:endParaRPr lang="en-US" altLang="ko-KR" sz="2800" dirty="0">
+              <a:solidFill>
+                <a:srgbClr val="212529"/>
+              </a:solidFill>
+              <a:latin typeface="+mn-ea"/>
+            </a:endParaRPr>
+          </a:p>
+          <a:p>
+            <a:pPr lvl="1"/>
+            <a:r>
+              <a:rPr lang="ko-KR" altLang="en-US" sz="2800" b="1" dirty="0">
+                <a:solidFill>
+                  <a:srgbClr val="212529"/>
+                </a:solidFill>
+                <a:latin typeface="+mn-ea"/>
+              </a:rPr>
+              <a:t>➡ </a:t>
+            </a:r>
+            <a:r>
+              <a:rPr lang="en-US" altLang="ko-KR" sz="2800" b="1" dirty="0">
+                <a:solidFill>
+                  <a:schemeClr val="accent1"/>
+                </a:solidFill>
+                <a:latin typeface="+mn-ea"/>
+              </a:rPr>
+              <a:t>[1</a:t>
+            </a:r>
+            <a:r>
+              <a:rPr lang="ko-KR" altLang="en-US" sz="2800" b="1" dirty="0">
+                <a:solidFill>
+                  <a:schemeClr val="accent1"/>
+                </a:solidFill>
+                <a:latin typeface="+mn-ea"/>
+              </a:rPr>
+              <a:t>번 문제</a:t>
+            </a:r>
+            <a:r>
+              <a:rPr lang="en-US" altLang="ko-KR" sz="2800" b="1" dirty="0">
+                <a:solidFill>
+                  <a:schemeClr val="accent1"/>
+                </a:solidFill>
+                <a:latin typeface="+mn-ea"/>
+              </a:rPr>
+              <a:t>]</a:t>
+            </a:r>
+            <a:r>
+              <a:rPr lang="en-US" altLang="ko-KR" sz="2800" dirty="0">
+                <a:solidFill>
+                  <a:schemeClr val="accent1"/>
+                </a:solidFill>
+                <a:latin typeface="+mn-ea"/>
+              </a:rPr>
+              <a:t> </a:t>
+            </a:r>
+            <a:r>
+              <a:rPr lang="ko-KR" altLang="en-US" sz="2800" dirty="0">
+                <a:solidFill>
+                  <a:srgbClr val="212529"/>
+                </a:solidFill>
+                <a:latin typeface="+mn-ea"/>
+              </a:rPr>
+              <a:t> 진행</a:t>
+            </a:r>
+          </a:p>
+        </p:txBody>
+      </p:sp>
     </p:spTree>
     <p:extLst>
       <p:ext uri="{BB962C8B-B14F-4D97-AF65-F5344CB8AC3E}">
-        <p14:creationId xmlns:p14="http://schemas.microsoft.com/office/powerpoint/2010/main" val="3253147892"/>
+        <p14:creationId xmlns:p14="http://schemas.microsoft.com/office/powerpoint/2010/main" val="3515274297"/>
       </p:ext>
     </p:extLst>
   </p:cSld>
@@ -7277,7 +8337,7 @@
           <a:p>
             <a:fld id="{CE27A22C-65A3-484B-AF1E-9F8BD90A2FC7}" type="datetime1">
               <a:rPr lang="ko-KR" altLang="en-US" smtClean="0"/>
-              <a:t>2024-07-05</a:t>
+              <a:t>2024-09-23</a:t>
             </a:fld>
             <a:endParaRPr lang="ko-KR" altLang="en-US"/>
           </a:p>
@@ -7556,4 +8616,319 @@
     </a:ext>
   </a:extLst>
 </a:theme>
+</file>
+
+<file path=ppt/theme/theme2.xml><?xml version="1.0" encoding="utf-8"?>
+<a:theme xmlns:a="http://schemas.openxmlformats.org/drawingml/2006/main" name="Office 테마">
+  <a:themeElements>
+    <a:clrScheme name="Office">
+      <a:dk1>
+        <a:sysClr val="windowText" lastClr="000000"/>
+      </a:dk1>
+      <a:lt1>
+        <a:sysClr val="window" lastClr="FFFFFF"/>
+      </a:lt1>
+      <a:dk2>
+        <a:srgbClr val="0E2841"/>
+      </a:dk2>
+      <a:lt2>
+        <a:srgbClr val="E8E8E8"/>
+      </a:lt2>
+      <a:accent1>
+        <a:srgbClr val="156082"/>
+      </a:accent1>
+      <a:accent2>
+        <a:srgbClr val="E97132"/>
+      </a:accent2>
+      <a:accent3>
+        <a:srgbClr val="196B24"/>
+      </a:accent3>
+      <a:accent4>
+        <a:srgbClr val="0F9ED5"/>
+      </a:accent4>
+      <a:accent5>
+        <a:srgbClr val="A02B93"/>
+      </a:accent5>
+      <a:accent6>
+        <a:srgbClr val="4EA72E"/>
+      </a:accent6>
+      <a:hlink>
+        <a:srgbClr val="467886"/>
+      </a:hlink>
+      <a:folHlink>
+        <a:srgbClr val="96607D"/>
+      </a:folHlink>
+    </a:clrScheme>
+    <a:fontScheme name="Office">
+      <a:majorFont>
+        <a:latin typeface="맑은 고딕" panose="02110004020202020204"/>
+        <a:ea typeface=""/>
+        <a:cs typeface=""/>
+        <a:font script="Jpan" typeface="游ゴシック Light"/>
+        <a:font script="Hang" typeface="맑은 고딕"/>
+        <a:font script="Hans" typeface="等线 Light"/>
+        <a:font script="Hant" typeface="新細明體"/>
+        <a:font script="Arab" typeface="Times New Roman"/>
+        <a:font script="Hebr" typeface="Times New Roman"/>
+        <a:font script="Thai" typeface="Angsana New"/>
+        <a:font script="Ethi" typeface="Nyala"/>
+        <a:font script="Beng" typeface="Vrinda"/>
+        <a:font script="Gujr" typeface="Shruti"/>
+        <a:font script="Khmr" typeface="MoolBoran"/>
+        <a:font script="Knda" typeface="Tunga"/>
+        <a:font script="Guru" typeface="Raavi"/>
+        <a:font script="Cans" typeface="Euphemia"/>
+        <a:font script="Cher" typeface="Plantagenet Cherokee"/>
+        <a:font script="Yiii" typeface="Microsoft Yi Baiti"/>
+        <a:font script="Tibt" typeface="Microsoft Himalaya"/>
+        <a:font script="Thaa" typeface="MV Boli"/>
+        <a:font script="Deva" typeface="Mangal"/>
+        <a:font script="Telu" typeface="Gautami"/>
+        <a:font script="Taml" typeface="Latha"/>
+        <a:font script="Syrc" typeface="Estrangelo Edessa"/>
+        <a:font script="Orya" typeface="Kalinga"/>
+        <a:font script="Mlym" typeface="Kartika"/>
+        <a:font script="Laoo" typeface="DokChampa"/>
+        <a:font script="Sinh" typeface="Iskoola Pota"/>
+        <a:font script="Mong" typeface="Mongolian Baiti"/>
+        <a:font script="Viet" typeface="Times New Roman"/>
+        <a:font script="Uigh" typeface="Microsoft Uighur"/>
+        <a:font script="Geor" typeface="Sylfaen"/>
+        <a:font script="Armn" typeface="Arial"/>
+        <a:font script="Bugi" typeface="Leelawadee UI"/>
+        <a:font script="Bopo" typeface="Microsoft JhengHei"/>
+        <a:font script="Java" typeface="Javanese Text"/>
+        <a:font script="Lisu" typeface="Segoe UI"/>
+        <a:font script="Mymr" typeface="Myanmar Text"/>
+        <a:font script="Nkoo" typeface="Ebrima"/>
+        <a:font script="Olck" typeface="Nirmala UI"/>
+        <a:font script="Osma" typeface="Ebrima"/>
+        <a:font script="Phag" typeface="Phagspa"/>
+        <a:font script="Syrn" typeface="Estrangelo Edessa"/>
+        <a:font script="Syrj" typeface="Estrangelo Edessa"/>
+        <a:font script="Syre" typeface="Estrangelo Edessa"/>
+        <a:font script="Sora" typeface="Nirmala UI"/>
+        <a:font script="Tale" typeface="Microsoft Tai Le"/>
+        <a:font script="Talu" typeface="Microsoft New Tai Lue"/>
+        <a:font script="Tfng" typeface="Ebrima"/>
+      </a:majorFont>
+      <a:minorFont>
+        <a:latin typeface="맑은 고딕" panose="02110004020202020204"/>
+        <a:ea typeface=""/>
+        <a:cs typeface=""/>
+        <a:font script="Jpan" typeface="游ゴシック"/>
+        <a:font script="Hang" typeface="맑은 고딕"/>
+        <a:font script="Hans" typeface="等线"/>
+        <a:font script="Hant" typeface="新細明體"/>
+        <a:font script="Arab" typeface="Arial"/>
+        <a:font script="Hebr" typeface="Arial"/>
+        <a:font script="Thai" typeface="Cordia New"/>
+        <a:font script="Ethi" typeface="Nyala"/>
+        <a:font script="Beng" typeface="Vrinda"/>
+        <a:font script="Gujr" typeface="Shruti"/>
+        <a:font script="Khmr" typeface="DaunPenh"/>
+        <a:font script="Knda" typeface="Tunga"/>
+        <a:font script="Guru" typeface="Raavi"/>
+        <a:font script="Cans" typeface="Euphemia"/>
+        <a:font script="Cher" typeface="Plantagenet Cherokee"/>
+        <a:font script="Yiii" typeface="Microsoft Yi Baiti"/>
+        <a:font script="Tibt" typeface="Microsoft Himalaya"/>
+        <a:font script="Thaa" typeface="MV Boli"/>
+        <a:font script="Deva" typeface="Mangal"/>
+        <a:font script="Telu" typeface="Gautami"/>
+        <a:font script="Taml" typeface="Latha"/>
+        <a:font script="Syrc" typeface="Estrangelo Edessa"/>
+        <a:font script="Orya" typeface="Kalinga"/>
+        <a:font script="Mlym" typeface="Kartika"/>
+        <a:font script="Laoo" typeface="DokChampa"/>
+        <a:font script="Sinh" typeface="Iskoola Pota"/>
+        <a:font script="Mong" typeface="Mongolian Baiti"/>
+        <a:font script="Viet" typeface="Arial"/>
+        <a:font script="Uigh" typeface="Microsoft Uighur"/>
+        <a:font script="Geor" typeface="Sylfaen"/>
+        <a:font script="Armn" typeface="Arial"/>
+        <a:font script="Bugi" typeface="Leelawadee UI"/>
+        <a:font script="Bopo" typeface="Microsoft JhengHei"/>
+        <a:font script="Java" typeface="Javanese Text"/>
+        <a:font script="Lisu" typeface="Segoe UI"/>
+        <a:font script="Mymr" typeface="Myanmar Text"/>
+        <a:font script="Nkoo" typeface="Ebrima"/>
+        <a:font script="Olck" typeface="Nirmala UI"/>
+        <a:font script="Osma" typeface="Ebrima"/>
+        <a:font script="Phag" typeface="Phagspa"/>
+        <a:font script="Syrn" typeface="Estrangelo Edessa"/>
+        <a:font script="Syrj" typeface="Estrangelo Edessa"/>
+        <a:font script="Syre" typeface="Estrangelo Edessa"/>
+        <a:font script="Sora" typeface="Nirmala UI"/>
+        <a:font script="Tale" typeface="Microsoft Tai Le"/>
+        <a:font script="Talu" typeface="Microsoft New Tai Lue"/>
+        <a:font script="Tfng" typeface="Ebrima"/>
+      </a:minorFont>
+    </a:fontScheme>
+    <a:fmtScheme name="Office">
+      <a:fillStyleLst>
+        <a:solidFill>
+          <a:schemeClr val="phClr"/>
+        </a:solidFill>
+        <a:gradFill rotWithShape="1">
+          <a:gsLst>
+            <a:gs pos="0">
+              <a:schemeClr val="phClr">
+                <a:lumMod val="110000"/>
+                <a:satMod val="105000"/>
+                <a:tint val="67000"/>
+              </a:schemeClr>
+            </a:gs>
+            <a:gs pos="50000">
+              <a:schemeClr val="phClr">
+                <a:lumMod val="105000"/>
+                <a:satMod val="103000"/>
+                <a:tint val="73000"/>
+              </a:schemeClr>
+            </a:gs>
+            <a:gs pos="100000">
+              <a:schemeClr val="phClr">
+                <a:lumMod val="105000"/>
+                <a:satMod val="109000"/>
+                <a:tint val="81000"/>
+              </a:schemeClr>
+            </a:gs>
+          </a:gsLst>
+          <a:lin ang="5400000" scaled="0"/>
+        </a:gradFill>
+        <a:gradFill rotWithShape="1">
+          <a:gsLst>
+            <a:gs pos="0">
+              <a:schemeClr val="phClr">
+                <a:satMod val="103000"/>
+                <a:lumMod val="102000"/>
+                <a:tint val="94000"/>
+              </a:schemeClr>
+            </a:gs>
+            <a:gs pos="50000">
+              <a:schemeClr val="phClr">
+                <a:satMod val="110000"/>
+                <a:lumMod val="100000"/>
+                <a:shade val="100000"/>
+              </a:schemeClr>
+            </a:gs>
+            <a:gs pos="100000">
+              <a:schemeClr val="phClr">
+                <a:lumMod val="99000"/>
+                <a:satMod val="120000"/>
+                <a:shade val="78000"/>
+              </a:schemeClr>
+            </a:gs>
+          </a:gsLst>
+          <a:lin ang="5400000" scaled="0"/>
+        </a:gradFill>
+      </a:fillStyleLst>
+      <a:lnStyleLst>
+        <a:ln w="12700" cap="flat" cmpd="sng" algn="ctr">
+          <a:solidFill>
+            <a:schemeClr val="phClr"/>
+          </a:solidFill>
+          <a:prstDash val="solid"/>
+          <a:miter lim="800000"/>
+        </a:ln>
+        <a:ln w="19050" cap="flat" cmpd="sng" algn="ctr">
+          <a:solidFill>
+            <a:schemeClr val="phClr"/>
+          </a:solidFill>
+          <a:prstDash val="solid"/>
+          <a:miter lim="800000"/>
+        </a:ln>
+        <a:ln w="25400" cap="flat" cmpd="sng" algn="ctr">
+          <a:solidFill>
+            <a:schemeClr val="phClr"/>
+          </a:solidFill>
+          <a:prstDash val="solid"/>
+          <a:miter lim="800000"/>
+        </a:ln>
+      </a:lnStyleLst>
+      <a:effectStyleLst>
+        <a:effectStyle>
+          <a:effectLst/>
+        </a:effectStyle>
+        <a:effectStyle>
+          <a:effectLst/>
+        </a:effectStyle>
+        <a:effectStyle>
+          <a:effectLst>
+            <a:outerShdw blurRad="57150" dist="19050" dir="5400000" algn="ctr" rotWithShape="0">
+              <a:srgbClr val="000000">
+                <a:alpha val="63000"/>
+              </a:srgbClr>
+            </a:outerShdw>
+          </a:effectLst>
+        </a:effectStyle>
+      </a:effectStyleLst>
+      <a:bgFillStyleLst>
+        <a:solidFill>
+          <a:schemeClr val="phClr"/>
+        </a:solidFill>
+        <a:solidFill>
+          <a:schemeClr val="phClr">
+            <a:tint val="95000"/>
+            <a:satMod val="170000"/>
+          </a:schemeClr>
+        </a:solidFill>
+        <a:gradFill rotWithShape="1">
+          <a:gsLst>
+            <a:gs pos="0">
+              <a:schemeClr val="phClr">
+                <a:tint val="93000"/>
+                <a:satMod val="150000"/>
+                <a:shade val="98000"/>
+                <a:lumMod val="102000"/>
+              </a:schemeClr>
+            </a:gs>
+            <a:gs pos="50000">
+              <a:schemeClr val="phClr">
+                <a:tint val="98000"/>
+                <a:satMod val="130000"/>
+                <a:shade val="90000"/>
+                <a:lumMod val="103000"/>
+              </a:schemeClr>
+            </a:gs>
+            <a:gs pos="100000">
+              <a:schemeClr val="phClr">
+                <a:shade val="63000"/>
+                <a:satMod val="120000"/>
+              </a:schemeClr>
+            </a:gs>
+          </a:gsLst>
+          <a:lin ang="5400000" scaled="0"/>
+        </a:gradFill>
+      </a:bgFillStyleLst>
+    </a:fmtScheme>
+  </a:themeElements>
+  <a:objectDefaults>
+    <a:lnDef>
+      <a:spPr/>
+      <a:bodyPr/>
+      <a:lstStyle/>
+      <a:style>
+        <a:lnRef idx="2">
+          <a:schemeClr val="accent1"/>
+        </a:lnRef>
+        <a:fillRef idx="0">
+          <a:schemeClr val="accent1"/>
+        </a:fillRef>
+        <a:effectRef idx="1">
+          <a:schemeClr val="accent1"/>
+        </a:effectRef>
+        <a:fontRef idx="minor">
+          <a:schemeClr val="tx1"/>
+        </a:fontRef>
+      </a:style>
+    </a:lnDef>
+  </a:objectDefaults>
+  <a:extraClrSchemeLst/>
+  <a:extLst>
+    <a:ext uri="{05A4C25C-085E-4340-85A3-A5531E510DB2}">
+      <thm15:themeFamily xmlns:thm15="http://schemas.microsoft.com/office/thememl/2012/main" name="Office Theme" id="{2E142A2C-CD16-42D6-873A-C26D2A0506FA}" vid="{1BDDFF52-6CD6-40A5-AB3C-68EB2F1E4D0A}"/>
+    </a:ext>
+  </a:extLst>
+</a:theme>
 </file>
</xml_diff>